<commit_message>
Replace presentation with buyer-facing deck
</commit_message>
<xml_diff>
--- a/Jarvis_Workforce_HQ_Growth_Deck.pptx
+++ b/Jarvis_Workforce_HQ_Growth_Deck.pptx
@@ -2,23 +2,23 @@
 <file path=ppt/presentation.xml><?xml version="1.0" encoding="utf-8"?>
 <p:presentation xmlns:p="http://schemas.openxmlformats.org/presentationml/2006/main">
   <p:sldMasterIdLst>
-    <p:sldMasterId xmlns:r="http://schemas.openxmlformats.org/officeDocument/2006/relationships" id="2147483648" r:id="R2bd7db418c1b4118"/>
+    <p:sldMasterId xmlns:r="http://schemas.openxmlformats.org/officeDocument/2006/relationships" id="2147483648" r:id="R4db7684a7db04f7a"/>
   </p:sldMasterIdLst>
   <p:notesMasterIdLst>
-    <p:notesMasterId xmlns:r="http://schemas.openxmlformats.org/officeDocument/2006/relationships" r:id="R5884674870444194"/>
+    <p:notesMasterId xmlns:r="http://schemas.openxmlformats.org/officeDocument/2006/relationships" r:id="Rfe7fd35b4e214d0c"/>
   </p:notesMasterIdLst>
   <p:sldIdLst>
-    <p:sldId xmlns:r="http://schemas.openxmlformats.org/officeDocument/2006/relationships" id="256" r:id="Rd12fbfc028ae4e9a"/>
-    <p:sldId xmlns:r="http://schemas.openxmlformats.org/officeDocument/2006/relationships" id="257" r:id="Rf874e91ff3cd4fb8"/>
-    <p:sldId xmlns:r="http://schemas.openxmlformats.org/officeDocument/2006/relationships" id="258" r:id="R794f54b0d23b41b9"/>
-    <p:sldId xmlns:r="http://schemas.openxmlformats.org/officeDocument/2006/relationships" id="259" r:id="Rb1954e046ddc4448"/>
-    <p:sldId xmlns:r="http://schemas.openxmlformats.org/officeDocument/2006/relationships" id="260" r:id="R38e284d5bb144f92"/>
-    <p:sldId xmlns:r="http://schemas.openxmlformats.org/officeDocument/2006/relationships" id="261" r:id="R7efc60c911894496"/>
-    <p:sldId xmlns:r="http://schemas.openxmlformats.org/officeDocument/2006/relationships" id="262" r:id="R5e7295bf119e42cf"/>
-    <p:sldId xmlns:r="http://schemas.openxmlformats.org/officeDocument/2006/relationships" id="263" r:id="R08064907153c4680"/>
-    <p:sldId xmlns:r="http://schemas.openxmlformats.org/officeDocument/2006/relationships" id="264" r:id="Rb1b8cca239244f55"/>
-    <p:sldId xmlns:r="http://schemas.openxmlformats.org/officeDocument/2006/relationships" id="265" r:id="Re1627106b8554bc8"/>
-    <p:sldId xmlns:r="http://schemas.openxmlformats.org/officeDocument/2006/relationships" id="266" r:id="R3e379e8823884419"/>
+    <p:sldId xmlns:r="http://schemas.openxmlformats.org/officeDocument/2006/relationships" id="256" r:id="R788f1a10e4ed4d6e"/>
+    <p:sldId xmlns:r="http://schemas.openxmlformats.org/officeDocument/2006/relationships" id="257" r:id="R68690808fb9f4986"/>
+    <p:sldId xmlns:r="http://schemas.openxmlformats.org/officeDocument/2006/relationships" id="258" r:id="R5bc0ce3c9b654359"/>
+    <p:sldId xmlns:r="http://schemas.openxmlformats.org/officeDocument/2006/relationships" id="259" r:id="R91f4979c92094986"/>
+    <p:sldId xmlns:r="http://schemas.openxmlformats.org/officeDocument/2006/relationships" id="260" r:id="R07b9b38859ef4eb1"/>
+    <p:sldId xmlns:r="http://schemas.openxmlformats.org/officeDocument/2006/relationships" id="261" r:id="R4d3382c863ca4893"/>
+    <p:sldId xmlns:r="http://schemas.openxmlformats.org/officeDocument/2006/relationships" id="262" r:id="Rd2035cb63d3a46d3"/>
+    <p:sldId xmlns:r="http://schemas.openxmlformats.org/officeDocument/2006/relationships" id="263" r:id="R96066a817572407d"/>
+    <p:sldId xmlns:r="http://schemas.openxmlformats.org/officeDocument/2006/relationships" id="264" r:id="Rbb475acbedf04f66"/>
+    <p:sldId xmlns:r="http://schemas.openxmlformats.org/officeDocument/2006/relationships" id="265" r:id="R2107403d7e724638"/>
+    <p:sldId xmlns:r="http://schemas.openxmlformats.org/officeDocument/2006/relationships" id="266" r:id="R6185013daa0c44d7"/>
   </p:sldIdLst>
   <p:sldSz cx="12192000" cy="6858000"/>
   <p:notesSz cx="6858000" cy="9144000"/>
@@ -547,7 +547,7 @@
           <a:lstStyle xmlns:a="http://schemas.openxmlformats.org/drawingml/2006/main"/>
           <a:p xmlns:a="http://schemas.openxmlformats.org/drawingml/2006/main">
             <a:r>
-              <a:t>Opening: the product is a supervised outcome system, not a collection of chatbots.</a:t>
+              <a:t>Opening: Jarvis Workforce HQ begins with one supervised workflow and preserves human approval.</a:t>
             </a:r>
           </a:p>
         </p:txBody>
@@ -687,7 +687,12 @@
           <a:lstStyle xmlns:a="http://schemas.openxmlformats.org/drawingml/2006/main"/>
           <a:p xmlns:a="http://schemas.openxmlformats.org/drawingml/2006/main">
             <a:r>
-              <a:t/>
+              <a:t>[Sources]</a:t>
+            </a:r>
+          </a:p>
+          <a:p xmlns:a="http://schemas.openxmlformats.org/drawingml/2006/main">
+            <a:r>
+              <a:t>- Timeline is an illustrative implementation sequence; final scope depends on workflow access, risk, and approvals.</a:t>
             </a:r>
           </a:p>
         </p:txBody>
@@ -762,12 +767,7 @@
           </a:p>
           <a:p xmlns:a="http://schemas.openxmlformats.org/drawingml/2006/main">
             <a:r>
-              <a:t>McKinsey, The State of AI (2025): https://www.mckinsey.com/capabilities/quantumblack/our-insights/the-state-of-ai</a:t>
-            </a:r>
-          </a:p>
-          <a:p xmlns:a="http://schemas.openxmlformats.org/drawingml/2006/main">
-            <a:r>
-              <a:t>U.S. Small Business Administration, 2025 Small Business Profile: https://advocacy.sba.gov/wp-content/uploads/2025/06/United_States_2025-State-Profile.pdf</a:t>
+              <a:t>- No external numerical claims. Buyer-facing workflow statements describe intended product outcomes to validate in a pilot.</a:t>
             </a:r>
           </a:p>
         </p:txBody>
@@ -1052,7 +1052,7 @@
           </a:p>
           <a:p xmlns:a="http://schemas.openxmlformats.org/drawingml/2006/main">
             <a:r>
-              <a:t>FTC Endorsement Guides and testimonial disclosure guidance: https://www.ftc.gov/business-guidance/advertising-marketing/endorsements-influencers-reviews</a:t>
+              <a:t>- No claimed customer results. All pilot outcomes must be measured and approved before reuse.</a:t>
             </a:r>
           </a:p>
         </p:txBody>
@@ -1192,7 +1192,12 @@
           <a:lstStyle xmlns:a="http://schemas.openxmlformats.org/drawingml/2006/main"/>
           <a:p xmlns:a="http://schemas.openxmlformats.org/drawingml/2006/main">
             <a:r>
-              <a:t/>
+              <a:t>[Sources]</a:t>
+            </a:r>
+          </a:p>
+          <a:p xmlns:a="http://schemas.openxmlformats.org/drawingml/2006/main">
+            <a:r>
+              <a:t>- Pricing aligned with the Jarvis Workforce HQ website on 2026-07-30: https://darnleyweekes-spec.github.io/jarvis-workforce-hq/</a:t>
             </a:r>
           </a:p>
         </p:txBody>
@@ -1262,7 +1267,12 @@
           <a:lstStyle xmlns:a="http://schemas.openxmlformats.org/drawingml/2006/main"/>
           <a:p xmlns:a="http://schemas.openxmlformats.org/drawingml/2006/main">
             <a:r>
-              <a:t/>
+              <a:t>[Sources]</a:t>
+            </a:r>
+          </a:p>
+          <a:p xmlns:a="http://schemas.openxmlformats.org/drawingml/2006/main">
+            <a:r>
+              <a:t>- Scorecard measures are proposed evaluation criteria, not claimed customer outcomes.</a:t>
             </a:r>
           </a:p>
         </p:txBody>
@@ -1330,7 +1340,7 @@
   </p:cSld>
   <p:clrMap bg1="lt1" tx1="dk1" bg2="lt2" tx2="dk2" accent1="accent1" accent2="accent2" accent3="accent3" accent4="accent4" accent5="accent5" accent6="accent6" hlink="hlink" folHlink="folHlink"/>
   <p:sldLayoutIdLst>
-    <p:sldLayoutId xmlns:r="http://schemas.openxmlformats.org/officeDocument/2006/relationships" id="2147483649" r:id="Re4bd0834e35e4e71"/>
+    <p:sldLayoutId xmlns:r="http://schemas.openxmlformats.org/officeDocument/2006/relationships" id="2147483649" r:id="Rf2e5472bbefa4b03"/>
   </p:sldLayoutIdLst>
   <p:txStyles>
     <p:titleStyle>
@@ -1869,7 +1879,7 @@
           <c:idx val="0"/>
           <c:order val="0"/>
           <c:tx>
-            <c:v>Monthly revenue</c:v>
+            <c:v>Baseline index</c:v>
           </c:tx>
           <c:spPr>
             <a:solidFill xmlns:a="http://schemas.openxmlformats.org/drawingml/2006/main">
@@ -1880,16 +1890,13 @@
             <c:strLit>
               <c:ptCount val="3"/>
               <c:pt idx="0">
-                <c:v>Validation
-5 clients</c:v>
+                <c:v>Response time</c:v>
               </c:pt>
               <c:pt idx="1">
-                <c:v>Traction
-15 clients</c:v>
+                <c:v>Completion</c:v>
               </c:pt>
               <c:pt idx="2">
-                <c:v>Scale
-40 clients</c:v>
+                <c:v>Admin effort</c:v>
               </c:pt>
             </c:strLit>
           </c:cat>
@@ -1898,13 +1905,13 @@
               <c:formatCode>General</c:formatCode>
               <c:ptCount val="3"/>
               <c:pt idx="0">
-                <c:v>15500</c:v>
+                <c:v>100</c:v>
               </c:pt>
               <c:pt idx="1">
-                <c:v>43500</c:v>
+                <c:v>75</c:v>
               </c:pt>
               <c:pt idx="2">
-                <c:v>112000</c:v>
+                <c:v>100</c:v>
               </c:pt>
             </c:numLit>
           </c:val>
@@ -1913,7 +1920,7 @@
           <c:idx val="1"/>
           <c:order val="1"/>
           <c:tx>
-            <c:v>Illustrative gross profit</c:v>
+            <c:v>Illustrative pilot target</c:v>
           </c:tx>
           <c:spPr>
             <a:solidFill xmlns:a="http://schemas.openxmlformats.org/drawingml/2006/main">
@@ -1924,16 +1931,13 @@
             <c:strLit>
               <c:ptCount val="3"/>
               <c:pt idx="0">
-                <c:v>Validation
-5 clients</c:v>
+                <c:v>Response time</c:v>
               </c:pt>
               <c:pt idx="1">
-                <c:v>Traction
-15 clients</c:v>
+                <c:v>Completion</c:v>
               </c:pt>
               <c:pt idx="2">
-                <c:v>Scale
-40 clients</c:v>
+                <c:v>Admin effort</c:v>
               </c:pt>
             </c:strLit>
           </c:cat>
@@ -1942,13 +1946,13 @@
               <c:formatCode>General</c:formatCode>
               <c:ptCount val="3"/>
               <c:pt idx="0">
-                <c:v>12400</c:v>
+                <c:v>60</c:v>
               </c:pt>
               <c:pt idx="1">
-                <c:v>34800</c:v>
+                <c:v>95</c:v>
               </c:pt>
               <c:pt idx="2">
-                <c:v>89600</c:v>
+                <c:v>70</c:v>
               </c:pt>
             </c:numLit>
           </c:val>
@@ -1980,7 +1984,7 @@
               <a:lstStyle xmlns:a="http://schemas.openxmlformats.org/drawingml/2006/main"/>
               <a:p xmlns:a="http://schemas.openxmlformats.org/drawingml/2006/main">
                 <a:r>
-                  <a:t>Monthly scenario</a:t>
+                  <a:t>Scorecard dimension</a:t>
                 </a:r>
               </a:p>
             </c:rich>
@@ -2019,6 +2023,8 @@
         <c:axId val="48672768"/>
         <c:scaling>
           <c:orientation val="minMax"/>
+          <c:max val="120"/>
+          <c:min val="0"/>
         </c:scaling>
         <c:delete val="0"/>
         <c:axPos val="l"/>
@@ -2032,7 +2038,20 @@
             </a:ln>
           </c:spPr>
         </c:majorGridlines>
-        <c:numFmt formatCode="General"/>
+        <c:title>
+          <c:tx>
+            <c:rich>
+              <a:bodyPr xmlns:a="http://schemas.openxmlformats.org/drawingml/2006/main"/>
+              <a:lstStyle xmlns:a="http://schemas.openxmlformats.org/drawingml/2006/main"/>
+              <a:p xmlns:a="http://schemas.openxmlformats.org/drawingml/2006/main">
+                <a:r>
+                  <a:t>Index (baseline = 100)</a:t>
+                </a:r>
+              </a:p>
+            </c:rich>
+          </c:tx>
+        </c:title>
+        <c:numFmt formatCode="0"/>
         <c:majorTickMark val="none"/>
         <c:minorTickMark val="none"/>
         <c:spPr>
@@ -2058,7 +2077,7 @@
         </c:txPr>
         <c:crossAx val="48650112"/>
         <c:crossBetween val="between"/>
-        <c:majorUnit val="30000"/>
+        <c:majorUnit val="20"/>
       </c:valAx>
     </c:plotArea>
     <c:legend>
@@ -2091,14 +2110,14 @@
       </p:grpSpPr>
       <p:pic>
         <p:nvPicPr>
-          <p:cNvPr id="7" name=""/>
+          <p:cNvPr id="8" name=""/>
           <p:cNvPicPr>
             <a:picLocks xmlns:a="http://schemas.openxmlformats.org/drawingml/2006/main" noChangeAspect="1"/>
           </p:cNvPicPr>
           <p:nvPr/>
         </p:nvPicPr>
         <p:blipFill>
-          <a:blip xmlns:r="http://schemas.openxmlformats.org/officeDocument/2006/relationships" xmlns:a="http://schemas.openxmlformats.org/drawingml/2006/main" r:embed="R63936f8d86714085"/>
+          <a:blip xmlns:r="http://schemas.openxmlformats.org/officeDocument/2006/relationships" xmlns:a="http://schemas.openxmlformats.org/drawingml/2006/main" r:embed="Re42fb667e02345fe"/>
           <a:srcRect xmlns:a="http://schemas.openxmlformats.org/drawingml/2006/main" l="20688" t="0" r="20688" b="0"/>
           <a:stretch xmlns:a="http://schemas.openxmlformats.org/drawingml/2006/main">
             <a:fillRect l="0" t="0" r="0" b="0"/>
@@ -2175,6 +2194,7 @@
           <a:lstStyle xmlns:a="http://schemas.openxmlformats.org/drawingml/2006/main"/>
           <a:p xmlns:a="http://schemas.openxmlformats.org/drawingml/2006/main">
             <a:pPr algn="l">
+              <a:buNone/>
               <a:defRPr sz="975" b="1">
                 <a:solidFill>
                   <a:srgbClr val="38E8FF"/>
@@ -2225,6 +2245,7 @@
           <a:lstStyle xmlns:a="http://schemas.openxmlformats.org/drawingml/2006/main"/>
           <a:p xmlns:a="http://schemas.openxmlformats.org/drawingml/2006/main">
             <a:pPr algn="l">
+              <a:buNone/>
               <a:defRPr sz="3825" b="1">
                 <a:solidFill>
                   <a:srgbClr val="F4FBFF"/>
@@ -2242,6 +2263,7 @@
           </a:p>
           <a:p xmlns:a="http://schemas.openxmlformats.org/drawingml/2006/main">
             <a:pPr algn="l">
+              <a:buNone/>
               <a:defRPr sz="3825" b="1">
                 <a:solidFill>
                   <a:srgbClr val="F4FBFF"/>
@@ -2259,6 +2281,7 @@
           </a:p>
           <a:p xmlns:a="http://schemas.openxmlformats.org/drawingml/2006/main">
             <a:pPr algn="l">
+              <a:buNone/>
               <a:defRPr sz="3825" b="1">
                 <a:solidFill>
                   <a:srgbClr val="F4FBFF"/>
@@ -2309,6 +2332,7 @@
           <a:lstStyle xmlns:a="http://schemas.openxmlformats.org/drawingml/2006/main"/>
           <a:p xmlns:a="http://schemas.openxmlformats.org/drawingml/2006/main">
             <a:pPr algn="l">
+              <a:buNone/>
               <a:defRPr sz="1425" b="0">
                 <a:solidFill>
                   <a:srgbClr val="8EA7B7"/>
@@ -2321,7 +2345,7 @@
                   <a:srgbClr val="8EA7B7"/>
                 </a:solidFill>
               </a:rPr>
-              <a:t>A market-ready product, proof system, and recurring-revenue model for owner-led service businesses.</a:t>
+              <a:t>A buyer-ready blueprint for supervised AI workflows that protect human control.</a:t>
             </a:r>
           </a:p>
         </p:txBody>
@@ -2359,6 +2383,7 @@
           <a:lstStyle xmlns:a="http://schemas.openxmlformats.org/drawingml/2006/main"/>
           <a:p xmlns:a="http://schemas.openxmlformats.org/drawingml/2006/main">
             <a:pPr algn="l">
+              <a:buNone/>
               <a:defRPr sz="825" b="1">
                 <a:solidFill>
                   <a:srgbClr val="9AF4FF"/>
@@ -2371,7 +2396,7 @@
                   <a:srgbClr val="9AF4FF"/>
                 </a:solidFill>
               </a:rPr>
-              <a:t>ATTENTION  →  TRUST  →  PROOF  →  RETENTION</a:t>
+              <a:t>ONE WORKFLOW  →  HUMAN APPROVAL  →  MEASURED PROOF  →  CONTROLLED SCALE</a:t>
             </a:r>
           </a:p>
         </p:txBody>
@@ -2438,6 +2463,7 @@
           <a:lstStyle xmlns:a="http://schemas.openxmlformats.org/drawingml/2006/main"/>
           <a:p xmlns:a="http://schemas.openxmlformats.org/drawingml/2006/main">
             <a:pPr algn="l">
+              <a:buNone/>
               <a:defRPr sz="825" b="1">
                 <a:solidFill>
                   <a:srgbClr val="38E8FF"/>
@@ -2488,6 +2514,7 @@
           <a:lstStyle xmlns:a="http://schemas.openxmlformats.org/drawingml/2006/main"/>
           <a:p xmlns:a="http://schemas.openxmlformats.org/drawingml/2006/main">
             <a:pPr algn="r">
+              <a:buNone/>
               <a:defRPr sz="825" b="1">
                 <a:solidFill>
                   <a:srgbClr val="506B7B"/>
@@ -2538,6 +2565,7 @@
           <a:lstStyle xmlns:a="http://schemas.openxmlformats.org/drawingml/2006/main"/>
           <a:p xmlns:a="http://schemas.openxmlformats.org/drawingml/2006/main">
             <a:pPr algn="l">
+              <a:buNone/>
               <a:defRPr sz="3150" b="1">
                 <a:solidFill>
                   <a:srgbClr val="F4FBFF"/>
@@ -2588,6 +2616,7 @@
           <a:lstStyle xmlns:a="http://schemas.openxmlformats.org/drawingml/2006/main"/>
           <a:p xmlns:a="http://schemas.openxmlformats.org/drawingml/2006/main">
             <a:pPr algn="l">
+              <a:buNone/>
               <a:defRPr sz="1350" b="0">
                 <a:solidFill>
                   <a:srgbClr val="8EA7B7"/>
@@ -2638,6 +2667,7 @@
           <a:lstStyle xmlns:a="http://schemas.openxmlformats.org/drawingml/2006/main"/>
           <a:p xmlns:a="http://schemas.openxmlformats.org/drawingml/2006/main">
             <a:pPr algn="l">
+              <a:buNone/>
               <a:defRPr sz="825" b="1">
                 <a:solidFill>
                   <a:srgbClr val="38E8FF"/>
@@ -2688,6 +2718,7 @@
           <a:lstStyle xmlns:a="http://schemas.openxmlformats.org/drawingml/2006/main"/>
           <a:p xmlns:a="http://schemas.openxmlformats.org/drawingml/2006/main">
             <a:pPr algn="l">
+              <a:buNone/>
               <a:defRPr sz="1200" b="1">
                 <a:solidFill>
                   <a:srgbClr val="F4FBFF"/>
@@ -2738,6 +2769,7 @@
           <a:lstStyle xmlns:a="http://schemas.openxmlformats.org/drawingml/2006/main"/>
           <a:p xmlns:a="http://schemas.openxmlformats.org/drawingml/2006/main">
             <a:pPr algn="l">
+              <a:buNone/>
               <a:defRPr sz="1275" b="0">
                 <a:solidFill>
                   <a:srgbClr val="8EA7B7"/>
@@ -2819,6 +2851,7 @@
           <a:lstStyle xmlns:a="http://schemas.openxmlformats.org/drawingml/2006/main"/>
           <a:p xmlns:a="http://schemas.openxmlformats.org/drawingml/2006/main">
             <a:pPr algn="l">
+              <a:buNone/>
               <a:defRPr sz="825" b="1">
                 <a:solidFill>
                   <a:srgbClr val="38E8FF"/>
@@ -2869,6 +2902,7 @@
           <a:lstStyle xmlns:a="http://schemas.openxmlformats.org/drawingml/2006/main"/>
           <a:p xmlns:a="http://schemas.openxmlformats.org/drawingml/2006/main">
             <a:pPr algn="l">
+              <a:buNone/>
               <a:defRPr sz="1200" b="1">
                 <a:solidFill>
                   <a:srgbClr val="F4FBFF"/>
@@ -2919,6 +2953,7 @@
           <a:lstStyle xmlns:a="http://schemas.openxmlformats.org/drawingml/2006/main"/>
           <a:p xmlns:a="http://schemas.openxmlformats.org/drawingml/2006/main">
             <a:pPr algn="l">
+              <a:buNone/>
               <a:defRPr sz="1275" b="0">
                 <a:solidFill>
                   <a:srgbClr val="8EA7B7"/>
@@ -3000,6 +3035,7 @@
           <a:lstStyle xmlns:a="http://schemas.openxmlformats.org/drawingml/2006/main"/>
           <a:p xmlns:a="http://schemas.openxmlformats.org/drawingml/2006/main">
             <a:pPr algn="l">
+              <a:buNone/>
               <a:defRPr sz="825" b="1">
                 <a:solidFill>
                   <a:srgbClr val="38E8FF"/>
@@ -3050,6 +3086,7 @@
           <a:lstStyle xmlns:a="http://schemas.openxmlformats.org/drawingml/2006/main"/>
           <a:p xmlns:a="http://schemas.openxmlformats.org/drawingml/2006/main">
             <a:pPr algn="l">
+              <a:buNone/>
               <a:defRPr sz="1200" b="1">
                 <a:solidFill>
                   <a:srgbClr val="F4FBFF"/>
@@ -3100,6 +3137,7 @@
           <a:lstStyle xmlns:a="http://schemas.openxmlformats.org/drawingml/2006/main"/>
           <a:p xmlns:a="http://schemas.openxmlformats.org/drawingml/2006/main">
             <a:pPr algn="l">
+              <a:buNone/>
               <a:defRPr sz="1275" b="0">
                 <a:solidFill>
                   <a:srgbClr val="8EA7B7"/>
@@ -3181,6 +3219,7 @@
           <a:lstStyle xmlns:a="http://schemas.openxmlformats.org/drawingml/2006/main"/>
           <a:p xmlns:a="http://schemas.openxmlformats.org/drawingml/2006/main">
             <a:pPr algn="l">
+              <a:buNone/>
               <a:defRPr sz="825" b="1">
                 <a:solidFill>
                   <a:srgbClr val="38E8FF"/>
@@ -3231,6 +3270,7 @@
           <a:lstStyle xmlns:a="http://schemas.openxmlformats.org/drawingml/2006/main"/>
           <a:p xmlns:a="http://schemas.openxmlformats.org/drawingml/2006/main">
             <a:pPr algn="l">
+              <a:buNone/>
               <a:defRPr sz="1200" b="1">
                 <a:solidFill>
                   <a:srgbClr val="F4FBFF"/>
@@ -3281,6 +3321,7 @@
           <a:lstStyle xmlns:a="http://schemas.openxmlformats.org/drawingml/2006/main"/>
           <a:p xmlns:a="http://schemas.openxmlformats.org/drawingml/2006/main">
             <a:pPr algn="l">
+              <a:buNone/>
               <a:defRPr sz="1275" b="0">
                 <a:solidFill>
                   <a:srgbClr val="8EA7B7"/>
@@ -3362,6 +3403,7 @@
           <a:lstStyle xmlns:a="http://schemas.openxmlformats.org/drawingml/2006/main"/>
           <a:p xmlns:a="http://schemas.openxmlformats.org/drawingml/2006/main">
             <a:pPr algn="l">
+              <a:buNone/>
               <a:defRPr sz="825" b="1">
                 <a:solidFill>
                   <a:srgbClr val="38E8FF"/>
@@ -3412,6 +3454,7 @@
           <a:lstStyle xmlns:a="http://schemas.openxmlformats.org/drawingml/2006/main"/>
           <a:p xmlns:a="http://schemas.openxmlformats.org/drawingml/2006/main">
             <a:pPr algn="l">
+              <a:buNone/>
               <a:defRPr sz="1200" b="1">
                 <a:solidFill>
                   <a:srgbClr val="F4FBFF"/>
@@ -3462,6 +3505,7 @@
           <a:lstStyle xmlns:a="http://schemas.openxmlformats.org/drawingml/2006/main"/>
           <a:p xmlns:a="http://schemas.openxmlformats.org/drawingml/2006/main">
             <a:pPr algn="l">
+              <a:buNone/>
               <a:defRPr sz="1275" b="0">
                 <a:solidFill>
                   <a:srgbClr val="8EA7B7"/>
@@ -3572,6 +3616,7 @@
           <a:lstStyle xmlns:a="http://schemas.openxmlformats.org/drawingml/2006/main"/>
           <a:p xmlns:a="http://schemas.openxmlformats.org/drawingml/2006/main">
             <a:pPr algn="l">
+              <a:buNone/>
               <a:defRPr sz="825" b="1">
                 <a:solidFill>
                   <a:srgbClr val="38E8FF"/>
@@ -3584,7 +3629,7 @@
                   <a:srgbClr val="38E8FF"/>
                 </a:solidFill>
               </a:rPr>
-              <a:t>THE LAUNCH</a:t>
+              <a:t>THE ROLLOUT</a:t>
             </a:r>
           </a:p>
         </p:txBody>
@@ -3622,6 +3667,7 @@
           <a:lstStyle xmlns:a="http://schemas.openxmlformats.org/drawingml/2006/main"/>
           <a:p xmlns:a="http://schemas.openxmlformats.org/drawingml/2006/main">
             <a:pPr algn="r">
+              <a:buNone/>
               <a:defRPr sz="825" b="1">
                 <a:solidFill>
                   <a:srgbClr val="506B7B"/>
@@ -3672,6 +3718,7 @@
           <a:lstStyle xmlns:a="http://schemas.openxmlformats.org/drawingml/2006/main"/>
           <a:p xmlns:a="http://schemas.openxmlformats.org/drawingml/2006/main">
             <a:pPr algn="l">
+              <a:buNone/>
               <a:defRPr sz="3150" b="1">
                 <a:solidFill>
                   <a:srgbClr val="F4FBFF"/>
@@ -3684,7 +3731,7 @@
                   <a:srgbClr val="F4FBFF"/>
                 </a:solidFill>
               </a:rPr>
-              <a:t>Thirty days to the first verified, repeatable proof.</a:t>
+              <a:t>Thirty days to a decision-ready pilot.</a:t>
             </a:r>
           </a:p>
         </p:txBody>
@@ -3722,6 +3769,7 @@
           <a:lstStyle xmlns:a="http://schemas.openxmlformats.org/drawingml/2006/main"/>
           <a:p xmlns:a="http://schemas.openxmlformats.org/drawingml/2006/main">
             <a:pPr algn="l">
+              <a:buNone/>
               <a:defRPr sz="1350" b="0">
                 <a:solidFill>
                   <a:srgbClr val="8EA7B7"/>
@@ -3772,6 +3820,7 @@
           <a:lstStyle xmlns:a="http://schemas.openxmlformats.org/drawingml/2006/main"/>
           <a:p xmlns:a="http://schemas.openxmlformats.org/drawingml/2006/main">
             <a:pPr algn="l">
+              <a:buNone/>
               <a:defRPr sz="825" b="1">
                 <a:solidFill>
                   <a:srgbClr val="38E8FF"/>
@@ -3822,6 +3871,7 @@
           <a:lstStyle xmlns:a="http://schemas.openxmlformats.org/drawingml/2006/main"/>
           <a:p xmlns:a="http://schemas.openxmlformats.org/drawingml/2006/main">
             <a:pPr algn="l">
+              <a:buNone/>
               <a:defRPr sz="2250" b="1">
                 <a:solidFill>
                   <a:srgbClr val="F4FBFF"/>
@@ -3834,7 +3884,7 @@
                   <a:srgbClr val="F4FBFF"/>
                 </a:solidFill>
               </a:rPr>
-              <a:t>Focus</a:t>
+              <a:t>Scope</a:t>
             </a:r>
           </a:p>
         </p:txBody>
@@ -3872,6 +3922,7 @@
           <a:lstStyle xmlns:a="http://schemas.openxmlformats.org/drawingml/2006/main"/>
           <a:p xmlns:a="http://schemas.openxmlformats.org/drawingml/2006/main">
             <a:pPr algn="l">
+              <a:buNone/>
               <a:defRPr sz="1275" b="0">
                 <a:solidFill>
                   <a:srgbClr val="8EA7B7"/>
@@ -3884,7 +3935,7 @@
                   <a:srgbClr val="8EA7B7"/>
                 </a:solidFill>
               </a:rPr>
-              <a:t>Choose the brand, one vertical, one workflow, and one working demo.</a:t>
+              <a:t>Choose one workflow, define the baseline, name the approver, and confirm exclusions.</a:t>
             </a:r>
           </a:p>
         </p:txBody>
@@ -3953,6 +4004,7 @@
           <a:lstStyle xmlns:a="http://schemas.openxmlformats.org/drawingml/2006/main"/>
           <a:p xmlns:a="http://schemas.openxmlformats.org/drawingml/2006/main">
             <a:pPr algn="l">
+              <a:buNone/>
               <a:defRPr sz="825" b="1">
                 <a:solidFill>
                   <a:srgbClr val="38E8FF"/>
@@ -4003,6 +4055,7 @@
           <a:lstStyle xmlns:a="http://schemas.openxmlformats.org/drawingml/2006/main"/>
           <a:p xmlns:a="http://schemas.openxmlformats.org/drawingml/2006/main">
             <a:pPr algn="l">
+              <a:buNone/>
               <a:defRPr sz="2250" b="1">
                 <a:solidFill>
                   <a:srgbClr val="F4FBFF"/>
@@ -4015,7 +4068,7 @@
                   <a:srgbClr val="F4FBFF"/>
                 </a:solidFill>
               </a:rPr>
-              <a:t>Sell</a:t>
+              <a:t>Configure</a:t>
             </a:r>
           </a:p>
         </p:txBody>
@@ -4053,6 +4106,7 @@
           <a:lstStyle xmlns:a="http://schemas.openxmlformats.org/drawingml/2006/main"/>
           <a:p xmlns:a="http://schemas.openxmlformats.org/drawingml/2006/main">
             <a:pPr algn="l">
+              <a:buNone/>
               <a:defRPr sz="1275" b="0">
                 <a:solidFill>
                   <a:srgbClr val="8EA7B7"/>
@@ -4065,7 +4119,7 @@
                   <a:srgbClr val="8EA7B7"/>
                 </a:solidFill>
               </a:rPr>
-              <a:t>Contact 30 matched businesses daily and offer five founding proof sprints.</a:t>
+              <a:t>Map inputs, permissions, templates, escalation rules, and test cases.</a:t>
             </a:r>
           </a:p>
         </p:txBody>
@@ -4134,6 +4188,7 @@
           <a:lstStyle xmlns:a="http://schemas.openxmlformats.org/drawingml/2006/main"/>
           <a:p xmlns:a="http://schemas.openxmlformats.org/drawingml/2006/main">
             <a:pPr algn="l">
+              <a:buNone/>
               <a:defRPr sz="825" b="1">
                 <a:solidFill>
                   <a:srgbClr val="38E8FF"/>
@@ -4184,6 +4239,7 @@
           <a:lstStyle xmlns:a="http://schemas.openxmlformats.org/drawingml/2006/main"/>
           <a:p xmlns:a="http://schemas.openxmlformats.org/drawingml/2006/main">
             <a:pPr algn="l">
+              <a:buNone/>
               <a:defRPr sz="2250" b="1">
                 <a:solidFill>
                   <a:srgbClr val="F4FBFF"/>
@@ -4196,7 +4252,7 @@
                   <a:srgbClr val="F4FBFF"/>
                 </a:solidFill>
               </a:rPr>
-              <a:t>Prove</a:t>
+              <a:t>Pilot</a:t>
             </a:r>
           </a:p>
         </p:txBody>
@@ -4234,6 +4290,7 @@
           <a:lstStyle xmlns:a="http://schemas.openxmlformats.org/drawingml/2006/main"/>
           <a:p xmlns:a="http://schemas.openxmlformats.org/drawingml/2006/main">
             <a:pPr algn="l">
+              <a:buNone/>
               <a:defRPr sz="1275" b="0">
                 <a:solidFill>
                   <a:srgbClr val="8EA7B7"/>
@@ -4246,7 +4303,7 @@
                   <a:srgbClr val="8EA7B7"/>
                 </a:solidFill>
               </a:rPr>
-              <a:t>Run pilots in approval-only mode; record baselines, exceptions, and decisions.</a:t>
+              <a:t>Run approval-only; log output, corrections, exceptions, time, and quality.</a:t>
             </a:r>
           </a:p>
         </p:txBody>
@@ -4315,6 +4372,7 @@
           <a:lstStyle xmlns:a="http://schemas.openxmlformats.org/drawingml/2006/main"/>
           <a:p xmlns:a="http://schemas.openxmlformats.org/drawingml/2006/main">
             <a:pPr algn="l">
+              <a:buNone/>
               <a:defRPr sz="825" b="1">
                 <a:solidFill>
                   <a:srgbClr val="38E8FF"/>
@@ -4365,6 +4423,7 @@
           <a:lstStyle xmlns:a="http://schemas.openxmlformats.org/drawingml/2006/main"/>
           <a:p xmlns:a="http://schemas.openxmlformats.org/drawingml/2006/main">
             <a:pPr algn="l">
+              <a:buNone/>
               <a:defRPr sz="2250" b="1">
                 <a:solidFill>
                   <a:srgbClr val="F4FBFF"/>
@@ -4377,7 +4436,7 @@
                   <a:srgbClr val="F4FBFF"/>
                 </a:solidFill>
               </a:rPr>
-              <a:t>Publish</a:t>
+              <a:t>Decide</a:t>
             </a:r>
           </a:p>
         </p:txBody>
@@ -4415,6 +4474,7 @@
           <a:lstStyle xmlns:a="http://schemas.openxmlformats.org/drawingml/2006/main"/>
           <a:p xmlns:a="http://schemas.openxmlformats.org/drawingml/2006/main">
             <a:pPr algn="l">
+              <a:buNone/>
               <a:defRPr sz="1275" b="0">
                 <a:solidFill>
                   <a:srgbClr val="8EA7B7"/>
@@ -4427,7 +4487,7 @@
                   <a:srgbClr val="8EA7B7"/>
                 </a:solidFill>
               </a:rPr>
-              <a:t>Release the verified case study and sell the next cohort at standard pricing.</a:t>
+              <a:t>Review the evidence and choose whether to expand, revise, pause, or stop.</a:t>
             </a:r>
           </a:p>
         </p:txBody>
@@ -4531,6 +4591,7 @@
           <a:lstStyle xmlns:a="http://schemas.openxmlformats.org/drawingml/2006/main"/>
           <a:p xmlns:a="http://schemas.openxmlformats.org/drawingml/2006/main">
             <a:pPr algn="l">
+              <a:buNone/>
               <a:defRPr sz="825" b="1">
                 <a:solidFill>
                   <a:srgbClr val="38E8FF"/>
@@ -4581,6 +4642,7 @@
           <a:lstStyle xmlns:a="http://schemas.openxmlformats.org/drawingml/2006/main"/>
           <a:p xmlns:a="http://schemas.openxmlformats.org/drawingml/2006/main">
             <a:pPr algn="l">
+              <a:buNone/>
               <a:defRPr sz="1500" b="1">
                 <a:solidFill>
                   <a:srgbClr val="F4FBFF"/>
@@ -4593,7 +4655,7 @@
                   <a:srgbClr val="F4FBFF"/>
                 </a:solidFill>
               </a:rPr>
-              <a:t>Approve one vertical + one founding workflow, then let Jarvis coordinate the mission.</a:t>
+              <a:t>Approve one bounded workflow for a 48-hour blueprint review.</a:t>
             </a:r>
           </a:p>
         </p:txBody>
@@ -4660,6 +4722,7 @@
           <a:lstStyle xmlns:a="http://schemas.openxmlformats.org/drawingml/2006/main"/>
           <a:p xmlns:a="http://schemas.openxmlformats.org/drawingml/2006/main">
             <a:pPr algn="l">
+              <a:buNone/>
               <a:defRPr sz="825" b="1">
                 <a:solidFill>
                   <a:srgbClr val="38E8FF"/>
@@ -4672,7 +4735,7 @@
                   <a:srgbClr val="38E8FF"/>
                 </a:solidFill>
               </a:rPr>
-              <a:t>THE OPENING</a:t>
+              <a:t>THE BUSINESS CASE</a:t>
             </a:r>
           </a:p>
         </p:txBody>
@@ -4710,6 +4773,7 @@
           <a:lstStyle xmlns:a="http://schemas.openxmlformats.org/drawingml/2006/main"/>
           <a:p xmlns:a="http://schemas.openxmlformats.org/drawingml/2006/main">
             <a:pPr algn="r">
+              <a:buNone/>
               <a:defRPr sz="825" b="1">
                 <a:solidFill>
                   <a:srgbClr val="506B7B"/>
@@ -4760,6 +4824,7 @@
           <a:lstStyle xmlns:a="http://schemas.openxmlformats.org/drawingml/2006/main"/>
           <a:p xmlns:a="http://schemas.openxmlformats.org/drawingml/2006/main">
             <a:pPr algn="l">
+              <a:buNone/>
               <a:defRPr sz="3150" b="1">
                 <a:solidFill>
                   <a:srgbClr val="F4FBFF"/>
@@ -4772,7 +4837,7 @@
                   <a:srgbClr val="F4FBFF"/>
                 </a:solidFill>
               </a:rPr>
-              <a:t>AI interest is widespread. Scaled execution is not.</a:t>
+              <a:t>Repetitive coordination steals time from customer work.</a:t>
             </a:r>
           </a:p>
         </p:txBody>
@@ -4810,6 +4875,7 @@
           <a:lstStyle xmlns:a="http://schemas.openxmlformats.org/drawingml/2006/main"/>
           <a:p xmlns:a="http://schemas.openxmlformats.org/drawingml/2006/main">
             <a:pPr algn="l">
+              <a:buNone/>
               <a:defRPr sz="1350" b="0">
                 <a:solidFill>
                   <a:srgbClr val="8EA7B7"/>
@@ -4822,7 +4888,7 @@
                   <a:srgbClr val="8EA7B7"/>
                 </a:solidFill>
               </a:rPr>
-              <a:t>The opportunity sits between experimentation and dependable operating value.</a:t>
+              <a:t>Start with one bounded workflow and prove the result before expanding.</a:t>
             </a:r>
           </a:p>
         </p:txBody>
@@ -4860,6 +4926,7 @@
           <a:lstStyle xmlns:a="http://schemas.openxmlformats.org/drawingml/2006/main"/>
           <a:p xmlns:a="http://schemas.openxmlformats.org/drawingml/2006/main">
             <a:pPr algn="l">
+              <a:buNone/>
               <a:defRPr sz="6150" b="1">
                 <a:solidFill>
                   <a:srgbClr val="38E8FF"/>
@@ -4872,7 +4939,7 @@
                   <a:srgbClr val="38E8FF"/>
                 </a:solidFill>
               </a:rPr>
-              <a:t>88%</a:t>
+              <a:t>FAST</a:t>
             </a:r>
           </a:p>
         </p:txBody>
@@ -4910,6 +4977,7 @@
           <a:lstStyle xmlns:a="http://schemas.openxmlformats.org/drawingml/2006/main"/>
           <a:p xmlns:a="http://schemas.openxmlformats.org/drawingml/2006/main">
             <a:pPr algn="l">
+              <a:buNone/>
               <a:defRPr sz="1500" b="1">
                 <a:solidFill>
                   <a:srgbClr val="F4FBFF"/>
@@ -4922,7 +4990,7 @@
                   <a:srgbClr val="F4FBFF"/>
                 </a:solidFill>
               </a:rPr>
-              <a:t>of surveyed organizations use AI in at least one business function.</a:t>
+              <a:t>first response on high-volume inquiries.</a:t>
             </a:r>
           </a:p>
         </p:txBody>
@@ -4991,6 +5059,7 @@
           <a:lstStyle xmlns:a="http://schemas.openxmlformats.org/drawingml/2006/main"/>
           <a:p xmlns:a="http://schemas.openxmlformats.org/drawingml/2006/main">
             <a:pPr algn="l">
+              <a:buNone/>
               <a:defRPr sz="5400" b="1">
                 <a:solidFill>
                   <a:srgbClr val="9AF4FF"/>
@@ -5003,7 +5072,7 @@
                   <a:srgbClr val="9AF4FF"/>
                 </a:solidFill>
               </a:rPr>
-              <a:t>≈ 2/3</a:t>
+              <a:t>FEWER</a:t>
             </a:r>
           </a:p>
         </p:txBody>
@@ -5041,6 +5110,7 @@
           <a:lstStyle xmlns:a="http://schemas.openxmlformats.org/drawingml/2006/main"/>
           <a:p xmlns:a="http://schemas.openxmlformats.org/drawingml/2006/main">
             <a:pPr algn="l">
+              <a:buNone/>
               <a:defRPr sz="1500" b="1">
                 <a:solidFill>
                   <a:srgbClr val="F4FBFF"/>
@@ -5053,7 +5123,7 @@
                   <a:srgbClr val="F4FBFF"/>
                 </a:solidFill>
               </a:rPr>
-              <a:t>had not yet begun scaling AI enterprise-wide.</a:t>
+              <a:t>dropped follow-ups, missing documents, and unclear handoffs.</a:t>
             </a:r>
           </a:p>
         </p:txBody>
@@ -5122,6 +5192,7 @@
           <a:lstStyle xmlns:a="http://schemas.openxmlformats.org/drawingml/2006/main"/>
           <a:p xmlns:a="http://schemas.openxmlformats.org/drawingml/2006/main">
             <a:pPr algn="l">
+              <a:buNone/>
               <a:defRPr sz="5400" b="1">
                 <a:solidFill>
                   <a:srgbClr val="8DFFBC"/>
@@ -5134,7 +5205,7 @@
                   <a:srgbClr val="8DFFBC"/>
                 </a:solidFill>
               </a:rPr>
-              <a:t>36.2M</a:t>
+              <a:t>CLEAR</a:t>
             </a:r>
           </a:p>
         </p:txBody>
@@ -5172,6 +5243,7 @@
           <a:lstStyle xmlns:a="http://schemas.openxmlformats.org/drawingml/2006/main"/>
           <a:p xmlns:a="http://schemas.openxmlformats.org/drawingml/2006/main">
             <a:pPr algn="l">
+              <a:buNone/>
               <a:defRPr sz="1500" b="1">
                 <a:solidFill>
                   <a:srgbClr val="F4FBFF"/>
@@ -5184,7 +5256,7 @@
                   <a:srgbClr val="F4FBFF"/>
                 </a:solidFill>
               </a:rPr>
-              <a:t>U.S. small businesses create a vast market for practical implementation.</a:t>
+              <a:t>visibility into workload, exceptions, and approvals.</a:t>
             </a:r>
           </a:p>
         </p:txBody>
@@ -5222,6 +5294,7 @@
           <a:lstStyle xmlns:a="http://schemas.openxmlformats.org/drawingml/2006/main"/>
           <a:p xmlns:a="http://schemas.openxmlformats.org/drawingml/2006/main">
             <a:pPr algn="ctr">
+              <a:buNone/>
               <a:defRPr sz="1800" b="0">
                 <a:solidFill>
                   <a:srgbClr val="8EA7B7"/>
@@ -5234,7 +5307,7 @@
                   <a:srgbClr val="8EA7B7"/>
                 </a:solidFill>
               </a:rPr>
-              <a:t>The wedge: help smaller teams install one measurable workflow with supervision, proof, and an accountable review point.</a:t>
+              <a:t>The first step: baseline one workflow, run it in approval-only mode, and compare time, quality, and throughput.</a:t>
             </a:r>
           </a:p>
         </p:txBody>
@@ -5301,6 +5374,7 @@
           <a:lstStyle xmlns:a="http://schemas.openxmlformats.org/drawingml/2006/main"/>
           <a:p xmlns:a="http://schemas.openxmlformats.org/drawingml/2006/main">
             <a:pPr algn="l">
+              <a:buNone/>
               <a:defRPr sz="825" b="1">
                 <a:solidFill>
                   <a:srgbClr val="38E8FF"/>
@@ -5351,6 +5425,7 @@
           <a:lstStyle xmlns:a="http://schemas.openxmlformats.org/drawingml/2006/main"/>
           <a:p xmlns:a="http://schemas.openxmlformats.org/drawingml/2006/main">
             <a:pPr algn="r">
+              <a:buNone/>
               <a:defRPr sz="825" b="1">
                 <a:solidFill>
                   <a:srgbClr val="506B7B"/>
@@ -5401,6 +5476,7 @@
           <a:lstStyle xmlns:a="http://schemas.openxmlformats.org/drawingml/2006/main"/>
           <a:p xmlns:a="http://schemas.openxmlformats.org/drawingml/2006/main">
             <a:pPr algn="l">
+              <a:buNone/>
               <a:defRPr sz="3150" b="1">
                 <a:solidFill>
                   <a:srgbClr val="F4FBFF"/>
@@ -5451,6 +5527,7 @@
           <a:lstStyle xmlns:a="http://schemas.openxmlformats.org/drawingml/2006/main"/>
           <a:p xmlns:a="http://schemas.openxmlformats.org/drawingml/2006/main">
             <a:pPr algn="l">
+              <a:buNone/>
               <a:defRPr sz="1350" b="0">
                 <a:solidFill>
                   <a:srgbClr val="8EA7B7"/>
@@ -5501,6 +5578,7 @@
           <a:lstStyle xmlns:a="http://schemas.openxmlformats.org/drawingml/2006/main"/>
           <a:p xmlns:a="http://schemas.openxmlformats.org/drawingml/2006/main">
             <a:pPr algn="l">
+              <a:buNone/>
               <a:defRPr sz="825" b="1">
                 <a:solidFill>
                   <a:srgbClr val="38E8FF"/>
@@ -5582,6 +5660,7 @@
           <a:lstStyle xmlns:a="http://schemas.openxmlformats.org/drawingml/2006/main"/>
           <a:p xmlns:a="http://schemas.openxmlformats.org/drawingml/2006/main">
             <a:pPr algn="l">
+              <a:buNone/>
               <a:defRPr sz="1875" b="1">
                 <a:solidFill>
                   <a:srgbClr val="F4FBFF"/>
@@ -5632,6 +5711,7 @@
           <a:lstStyle xmlns:a="http://schemas.openxmlformats.org/drawingml/2006/main"/>
           <a:p xmlns:a="http://schemas.openxmlformats.org/drawingml/2006/main">
             <a:pPr algn="l">
+              <a:buNone/>
               <a:defRPr sz="1275" b="0">
                 <a:solidFill>
                   <a:srgbClr val="8EA7B7"/>
@@ -5682,6 +5762,7 @@
           <a:lstStyle xmlns:a="http://schemas.openxmlformats.org/drawingml/2006/main"/>
           <a:p xmlns:a="http://schemas.openxmlformats.org/drawingml/2006/main">
             <a:pPr algn="ctr">
+              <a:buNone/>
               <a:defRPr sz="1875" b="1">
                 <a:solidFill>
                   <a:srgbClr val="506B7B"/>
@@ -5732,6 +5813,7 @@
           <a:lstStyle xmlns:a="http://schemas.openxmlformats.org/drawingml/2006/main"/>
           <a:p xmlns:a="http://schemas.openxmlformats.org/drawingml/2006/main">
             <a:pPr algn="l">
+              <a:buNone/>
               <a:defRPr sz="825" b="1">
                 <a:solidFill>
                   <a:srgbClr val="38E8FF"/>
@@ -5813,6 +5895,7 @@
           <a:lstStyle xmlns:a="http://schemas.openxmlformats.org/drawingml/2006/main"/>
           <a:p xmlns:a="http://schemas.openxmlformats.org/drawingml/2006/main">
             <a:pPr algn="l">
+              <a:buNone/>
               <a:defRPr sz="1875" b="1">
                 <a:solidFill>
                   <a:srgbClr val="F4FBFF"/>
@@ -5863,6 +5946,7 @@
           <a:lstStyle xmlns:a="http://schemas.openxmlformats.org/drawingml/2006/main"/>
           <a:p xmlns:a="http://schemas.openxmlformats.org/drawingml/2006/main">
             <a:pPr algn="l">
+              <a:buNone/>
               <a:defRPr sz="1275" b="0">
                 <a:solidFill>
                   <a:srgbClr val="8EA7B7"/>
@@ -5913,6 +5997,7 @@
           <a:lstStyle xmlns:a="http://schemas.openxmlformats.org/drawingml/2006/main"/>
           <a:p xmlns:a="http://schemas.openxmlformats.org/drawingml/2006/main">
             <a:pPr algn="ctr">
+              <a:buNone/>
               <a:defRPr sz="1875" b="1">
                 <a:solidFill>
                   <a:srgbClr val="506B7B"/>
@@ -5963,6 +6048,7 @@
           <a:lstStyle xmlns:a="http://schemas.openxmlformats.org/drawingml/2006/main"/>
           <a:p xmlns:a="http://schemas.openxmlformats.org/drawingml/2006/main">
             <a:pPr algn="l">
+              <a:buNone/>
               <a:defRPr sz="825" b="1">
                 <a:solidFill>
                   <a:srgbClr val="38E8FF"/>
@@ -6044,6 +6130,7 @@
           <a:lstStyle xmlns:a="http://schemas.openxmlformats.org/drawingml/2006/main"/>
           <a:p xmlns:a="http://schemas.openxmlformats.org/drawingml/2006/main">
             <a:pPr algn="l">
+              <a:buNone/>
               <a:defRPr sz="1875" b="1">
                 <a:solidFill>
                   <a:srgbClr val="F4FBFF"/>
@@ -6094,6 +6181,7 @@
           <a:lstStyle xmlns:a="http://schemas.openxmlformats.org/drawingml/2006/main"/>
           <a:p xmlns:a="http://schemas.openxmlformats.org/drawingml/2006/main">
             <a:pPr algn="l">
+              <a:buNone/>
               <a:defRPr sz="1275" b="0">
                 <a:solidFill>
                   <a:srgbClr val="8EA7B7"/>
@@ -6144,6 +6232,7 @@
           <a:lstStyle xmlns:a="http://schemas.openxmlformats.org/drawingml/2006/main"/>
           <a:p xmlns:a="http://schemas.openxmlformats.org/drawingml/2006/main">
             <a:pPr algn="ctr">
+              <a:buNone/>
               <a:defRPr sz="1875" b="1">
                 <a:solidFill>
                   <a:srgbClr val="506B7B"/>
@@ -6194,6 +6283,7 @@
           <a:lstStyle xmlns:a="http://schemas.openxmlformats.org/drawingml/2006/main"/>
           <a:p xmlns:a="http://schemas.openxmlformats.org/drawingml/2006/main">
             <a:pPr algn="l">
+              <a:buNone/>
               <a:defRPr sz="825" b="1">
                 <a:solidFill>
                   <a:srgbClr val="38E8FF"/>
@@ -6275,6 +6365,7 @@
           <a:lstStyle xmlns:a="http://schemas.openxmlformats.org/drawingml/2006/main"/>
           <a:p xmlns:a="http://schemas.openxmlformats.org/drawingml/2006/main">
             <a:pPr algn="l">
+              <a:buNone/>
               <a:defRPr sz="1875" b="1">
                 <a:solidFill>
                   <a:srgbClr val="F4FBFF"/>
@@ -6325,6 +6416,7 @@
           <a:lstStyle xmlns:a="http://schemas.openxmlformats.org/drawingml/2006/main"/>
           <a:p xmlns:a="http://schemas.openxmlformats.org/drawingml/2006/main">
             <a:pPr algn="l">
+              <a:buNone/>
               <a:defRPr sz="1275" b="0">
                 <a:solidFill>
                   <a:srgbClr val="8EA7B7"/>
@@ -6410,6 +6502,7 @@
           <a:lstStyle xmlns:a="http://schemas.openxmlformats.org/drawingml/2006/main"/>
           <a:p xmlns:a="http://schemas.openxmlformats.org/drawingml/2006/main">
             <a:pPr algn="l">
+              <a:buNone/>
               <a:defRPr sz="1650" b="1">
                 <a:solidFill>
                   <a:srgbClr val="38E8FF"/>
@@ -6460,6 +6553,7 @@
           <a:lstStyle xmlns:a="http://schemas.openxmlformats.org/drawingml/2006/main"/>
           <a:p xmlns:a="http://schemas.openxmlformats.org/drawingml/2006/main">
             <a:pPr algn="l">
+              <a:buNone/>
               <a:defRPr sz="1350" b="0">
                 <a:solidFill>
                   <a:srgbClr val="F4FBFF"/>
@@ -6539,6 +6633,7 @@
           <a:lstStyle xmlns:a="http://schemas.openxmlformats.org/drawingml/2006/main"/>
           <a:p xmlns:a="http://schemas.openxmlformats.org/drawingml/2006/main">
             <a:pPr algn="l">
+              <a:buNone/>
               <a:defRPr sz="825" b="1">
                 <a:solidFill>
                   <a:srgbClr val="38E8FF"/>
@@ -6589,6 +6684,7 @@
           <a:lstStyle xmlns:a="http://schemas.openxmlformats.org/drawingml/2006/main"/>
           <a:p xmlns:a="http://schemas.openxmlformats.org/drawingml/2006/main">
             <a:pPr algn="r">
+              <a:buNone/>
               <a:defRPr sz="825" b="1">
                 <a:solidFill>
                   <a:srgbClr val="506B7B"/>
@@ -6639,6 +6735,7 @@
           <a:lstStyle xmlns:a="http://schemas.openxmlformats.org/drawingml/2006/main"/>
           <a:p xmlns:a="http://schemas.openxmlformats.org/drawingml/2006/main">
             <a:pPr algn="l">
+              <a:buNone/>
               <a:defRPr sz="3150" b="1">
                 <a:solidFill>
                   <a:srgbClr val="F4FBFF"/>
@@ -6689,6 +6786,7 @@
           <a:lstStyle xmlns:a="http://schemas.openxmlformats.org/drawingml/2006/main"/>
           <a:p xmlns:a="http://schemas.openxmlformats.org/drawingml/2006/main">
             <a:pPr algn="l">
+              <a:buNone/>
               <a:defRPr sz="1350" b="0">
                 <a:solidFill>
                   <a:srgbClr val="8EA7B7"/>
@@ -6739,6 +6837,7 @@
           <a:lstStyle xmlns:a="http://schemas.openxmlformats.org/drawingml/2006/main"/>
           <a:p xmlns:a="http://schemas.openxmlformats.org/drawingml/2006/main">
             <a:pPr algn="l">
+              <a:buNone/>
               <a:defRPr sz="900" b="1">
                 <a:solidFill>
                   <a:srgbClr val="38E8FF"/>
@@ -6789,6 +6888,7 @@
           <a:lstStyle xmlns:a="http://schemas.openxmlformats.org/drawingml/2006/main"/>
           <a:p xmlns:a="http://schemas.openxmlformats.org/drawingml/2006/main">
             <a:pPr algn="l">
+              <a:buNone/>
               <a:defRPr sz="1275" b="1">
                 <a:solidFill>
                   <a:srgbClr val="F4FBFF"/>
@@ -6839,6 +6939,7 @@
           <a:lstStyle xmlns:a="http://schemas.openxmlformats.org/drawingml/2006/main"/>
           <a:p xmlns:a="http://schemas.openxmlformats.org/drawingml/2006/main">
             <a:pPr algn="l">
+              <a:buNone/>
               <a:defRPr sz="1200" b="0">
                 <a:solidFill>
                   <a:srgbClr val="8EA7B7"/>
@@ -6920,6 +7021,7 @@
           <a:lstStyle xmlns:a="http://schemas.openxmlformats.org/drawingml/2006/main"/>
           <a:p xmlns:a="http://schemas.openxmlformats.org/drawingml/2006/main">
             <a:pPr algn="l">
+              <a:buNone/>
               <a:defRPr sz="900" b="1">
                 <a:solidFill>
                   <a:srgbClr val="38E8FF"/>
@@ -6970,6 +7072,7 @@
           <a:lstStyle xmlns:a="http://schemas.openxmlformats.org/drawingml/2006/main"/>
           <a:p xmlns:a="http://schemas.openxmlformats.org/drawingml/2006/main">
             <a:pPr algn="l">
+              <a:buNone/>
               <a:defRPr sz="1275" b="1">
                 <a:solidFill>
                   <a:srgbClr val="F4FBFF"/>
@@ -7020,6 +7123,7 @@
           <a:lstStyle xmlns:a="http://schemas.openxmlformats.org/drawingml/2006/main"/>
           <a:p xmlns:a="http://schemas.openxmlformats.org/drawingml/2006/main">
             <a:pPr algn="l">
+              <a:buNone/>
               <a:defRPr sz="1200" b="0">
                 <a:solidFill>
                   <a:srgbClr val="8EA7B7"/>
@@ -7101,6 +7205,7 @@
           <a:lstStyle xmlns:a="http://schemas.openxmlformats.org/drawingml/2006/main"/>
           <a:p xmlns:a="http://schemas.openxmlformats.org/drawingml/2006/main">
             <a:pPr algn="l">
+              <a:buNone/>
               <a:defRPr sz="900" b="1">
                 <a:solidFill>
                   <a:srgbClr val="38E8FF"/>
@@ -7151,6 +7256,7 @@
           <a:lstStyle xmlns:a="http://schemas.openxmlformats.org/drawingml/2006/main"/>
           <a:p xmlns:a="http://schemas.openxmlformats.org/drawingml/2006/main">
             <a:pPr algn="l">
+              <a:buNone/>
               <a:defRPr sz="1275" b="1">
                 <a:solidFill>
                   <a:srgbClr val="F4FBFF"/>
@@ -7201,6 +7307,7 @@
           <a:lstStyle xmlns:a="http://schemas.openxmlformats.org/drawingml/2006/main"/>
           <a:p xmlns:a="http://schemas.openxmlformats.org/drawingml/2006/main">
             <a:pPr algn="l">
+              <a:buNone/>
               <a:defRPr sz="1200" b="0">
                 <a:solidFill>
                   <a:srgbClr val="8EA7B7"/>
@@ -7282,6 +7389,7 @@
           <a:lstStyle xmlns:a="http://schemas.openxmlformats.org/drawingml/2006/main"/>
           <a:p xmlns:a="http://schemas.openxmlformats.org/drawingml/2006/main">
             <a:pPr algn="l">
+              <a:buNone/>
               <a:defRPr sz="900" b="1">
                 <a:solidFill>
                   <a:srgbClr val="38E8FF"/>
@@ -7332,6 +7440,7 @@
           <a:lstStyle xmlns:a="http://schemas.openxmlformats.org/drawingml/2006/main"/>
           <a:p xmlns:a="http://schemas.openxmlformats.org/drawingml/2006/main">
             <a:pPr algn="l">
+              <a:buNone/>
               <a:defRPr sz="1275" b="1">
                 <a:solidFill>
                   <a:srgbClr val="F4FBFF"/>
@@ -7382,6 +7491,7 @@
           <a:lstStyle xmlns:a="http://schemas.openxmlformats.org/drawingml/2006/main"/>
           <a:p xmlns:a="http://schemas.openxmlformats.org/drawingml/2006/main">
             <a:pPr algn="l">
+              <a:buNone/>
               <a:defRPr sz="1200" b="0">
                 <a:solidFill>
                   <a:srgbClr val="8EA7B7"/>
@@ -7463,6 +7573,7 @@
           <a:lstStyle xmlns:a="http://schemas.openxmlformats.org/drawingml/2006/main"/>
           <a:p xmlns:a="http://schemas.openxmlformats.org/drawingml/2006/main">
             <a:pPr algn="l">
+              <a:buNone/>
               <a:defRPr sz="900" b="1">
                 <a:solidFill>
                   <a:srgbClr val="8DFFBC"/>
@@ -7513,6 +7624,7 @@
           <a:lstStyle xmlns:a="http://schemas.openxmlformats.org/drawingml/2006/main"/>
           <a:p xmlns:a="http://schemas.openxmlformats.org/drawingml/2006/main">
             <a:pPr algn="l">
+              <a:buNone/>
               <a:defRPr sz="1275" b="1">
                 <a:solidFill>
                   <a:srgbClr val="F4FBFF"/>
@@ -7563,6 +7675,7 @@
           <a:lstStyle xmlns:a="http://schemas.openxmlformats.org/drawingml/2006/main"/>
           <a:p xmlns:a="http://schemas.openxmlformats.org/drawingml/2006/main">
             <a:pPr algn="l">
+              <a:buNone/>
               <a:defRPr sz="1200" b="0">
                 <a:solidFill>
                   <a:srgbClr val="8EA7B7"/>
@@ -7673,6 +7786,7 @@
           <a:lstStyle xmlns:a="http://schemas.openxmlformats.org/drawingml/2006/main"/>
           <a:p xmlns:a="http://schemas.openxmlformats.org/drawingml/2006/main">
             <a:pPr algn="l">
+              <a:buNone/>
               <a:defRPr sz="825" b="1">
                 <a:solidFill>
                   <a:srgbClr val="38E8FF"/>
@@ -7723,6 +7837,7 @@
           <a:lstStyle xmlns:a="http://schemas.openxmlformats.org/drawingml/2006/main"/>
           <a:p xmlns:a="http://schemas.openxmlformats.org/drawingml/2006/main">
             <a:pPr algn="r">
+              <a:buNone/>
               <a:defRPr sz="825" b="1">
                 <a:solidFill>
                   <a:srgbClr val="506B7B"/>
@@ -7773,6 +7888,7 @@
           <a:lstStyle xmlns:a="http://schemas.openxmlformats.org/drawingml/2006/main"/>
           <a:p xmlns:a="http://schemas.openxmlformats.org/drawingml/2006/main">
             <a:pPr algn="l">
+              <a:buNone/>
               <a:defRPr sz="3150" b="1">
                 <a:solidFill>
                   <a:srgbClr val="F4FBFF"/>
@@ -7823,6 +7939,7 @@
           <a:lstStyle xmlns:a="http://schemas.openxmlformats.org/drawingml/2006/main"/>
           <a:p xmlns:a="http://schemas.openxmlformats.org/drawingml/2006/main">
             <a:pPr algn="l">
+              <a:buNone/>
               <a:defRPr sz="1350" b="0">
                 <a:solidFill>
                   <a:srgbClr val="8EA7B7"/>
@@ -7873,6 +7990,7 @@
           <a:lstStyle xmlns:a="http://schemas.openxmlformats.org/drawingml/2006/main"/>
           <a:p xmlns:a="http://schemas.openxmlformats.org/drawingml/2006/main">
             <a:pPr algn="l">
+              <a:buNone/>
               <a:defRPr sz="2175" b="1">
                 <a:solidFill>
                   <a:srgbClr val="F4FBFF"/>
@@ -7923,6 +8041,7 @@
           <a:lstStyle xmlns:a="http://schemas.openxmlformats.org/drawingml/2006/main"/>
           <a:p xmlns:a="http://schemas.openxmlformats.org/drawingml/2006/main">
             <a:pPr algn="l">
+              <a:buNone/>
               <a:defRPr sz="1275" b="1">
                 <a:solidFill>
                   <a:srgbClr val="8EA7B7"/>
@@ -7973,6 +8092,7 @@
           <a:lstStyle xmlns:a="http://schemas.openxmlformats.org/drawingml/2006/main"/>
           <a:p xmlns:a="http://schemas.openxmlformats.org/drawingml/2006/main">
             <a:pPr algn="l">
+              <a:buNone/>
               <a:defRPr sz="1200" b="0">
                 <a:solidFill>
                   <a:srgbClr val="506B7B"/>
@@ -8023,6 +8143,7 @@
           <a:lstStyle xmlns:a="http://schemas.openxmlformats.org/drawingml/2006/main"/>
           <a:p xmlns:a="http://schemas.openxmlformats.org/drawingml/2006/main">
             <a:pPr algn="l">
+              <a:buNone/>
               <a:defRPr sz="1275" b="1">
                 <a:solidFill>
                   <a:srgbClr val="8EA7B7"/>
@@ -8073,6 +8194,7 @@
           <a:lstStyle xmlns:a="http://schemas.openxmlformats.org/drawingml/2006/main"/>
           <a:p xmlns:a="http://schemas.openxmlformats.org/drawingml/2006/main">
             <a:pPr algn="l">
+              <a:buNone/>
               <a:defRPr sz="1200" b="0">
                 <a:solidFill>
                   <a:srgbClr val="506B7B"/>
@@ -8123,6 +8245,7 @@
           <a:lstStyle xmlns:a="http://schemas.openxmlformats.org/drawingml/2006/main"/>
           <a:p xmlns:a="http://schemas.openxmlformats.org/drawingml/2006/main">
             <a:pPr algn="l">
+              <a:buNone/>
               <a:defRPr sz="1275" b="1">
                 <a:solidFill>
                   <a:srgbClr val="8EA7B7"/>
@@ -8173,6 +8296,7 @@
           <a:lstStyle xmlns:a="http://schemas.openxmlformats.org/drawingml/2006/main"/>
           <a:p xmlns:a="http://schemas.openxmlformats.org/drawingml/2006/main">
             <a:pPr algn="l">
+              <a:buNone/>
               <a:defRPr sz="1200" b="0">
                 <a:solidFill>
                   <a:srgbClr val="506B7B"/>
@@ -8223,6 +8347,7 @@
           <a:lstStyle xmlns:a="http://schemas.openxmlformats.org/drawingml/2006/main"/>
           <a:p xmlns:a="http://schemas.openxmlformats.org/drawingml/2006/main">
             <a:pPr algn="l">
+              <a:buNone/>
               <a:defRPr sz="1275" b="1">
                 <a:solidFill>
                   <a:srgbClr val="8EA7B7"/>
@@ -8273,6 +8398,7 @@
           <a:lstStyle xmlns:a="http://schemas.openxmlformats.org/drawingml/2006/main"/>
           <a:p xmlns:a="http://schemas.openxmlformats.org/drawingml/2006/main">
             <a:pPr algn="l">
+              <a:buNone/>
               <a:defRPr sz="1200" b="0">
                 <a:solidFill>
                   <a:srgbClr val="506B7B"/>
@@ -8323,6 +8449,7 @@
           <a:lstStyle xmlns:a="http://schemas.openxmlformats.org/drawingml/2006/main"/>
           <a:p xmlns:a="http://schemas.openxmlformats.org/drawingml/2006/main">
             <a:pPr algn="ctr">
+              <a:buNone/>
               <a:defRPr sz="3300" b="1">
                 <a:solidFill>
                   <a:srgbClr val="38E8FF"/>
@@ -8408,6 +8535,7 @@
           <a:lstStyle xmlns:a="http://schemas.openxmlformats.org/drawingml/2006/main"/>
           <a:p xmlns:a="http://schemas.openxmlformats.org/drawingml/2006/main">
             <a:pPr algn="l">
+              <a:buNone/>
               <a:defRPr sz="825" b="1">
                 <a:solidFill>
                   <a:srgbClr val="38E8FF"/>
@@ -8458,6 +8586,7 @@
           <a:lstStyle xmlns:a="http://schemas.openxmlformats.org/drawingml/2006/main"/>
           <a:p xmlns:a="http://schemas.openxmlformats.org/drawingml/2006/main">
             <a:pPr algn="l">
+              <a:buNone/>
               <a:defRPr sz="825" b="1">
                 <a:solidFill>
                   <a:srgbClr val="9AF4FF"/>
@@ -8508,6 +8637,7 @@
           <a:lstStyle xmlns:a="http://schemas.openxmlformats.org/drawingml/2006/main"/>
           <a:p xmlns:a="http://schemas.openxmlformats.org/drawingml/2006/main">
             <a:pPr algn="l">
+              <a:buNone/>
               <a:defRPr sz="1275" b="0">
                 <a:solidFill>
                   <a:srgbClr val="F4FBFF"/>
@@ -8558,6 +8688,7 @@
           <a:lstStyle xmlns:a="http://schemas.openxmlformats.org/drawingml/2006/main"/>
           <a:p xmlns:a="http://schemas.openxmlformats.org/drawingml/2006/main">
             <a:pPr algn="l">
+              <a:buNone/>
               <a:defRPr sz="825" b="1">
                 <a:solidFill>
                   <a:srgbClr val="9AF4FF"/>
@@ -8608,6 +8739,7 @@
           <a:lstStyle xmlns:a="http://schemas.openxmlformats.org/drawingml/2006/main"/>
           <a:p xmlns:a="http://schemas.openxmlformats.org/drawingml/2006/main">
             <a:pPr algn="l">
+              <a:buNone/>
               <a:defRPr sz="1275" b="0">
                 <a:solidFill>
                   <a:srgbClr val="F4FBFF"/>
@@ -8658,6 +8790,7 @@
           <a:lstStyle xmlns:a="http://schemas.openxmlformats.org/drawingml/2006/main"/>
           <a:p xmlns:a="http://schemas.openxmlformats.org/drawingml/2006/main">
             <a:pPr algn="l">
+              <a:buNone/>
               <a:defRPr sz="825" b="1">
                 <a:solidFill>
                   <a:srgbClr val="9AF4FF"/>
@@ -8708,6 +8841,7 @@
           <a:lstStyle xmlns:a="http://schemas.openxmlformats.org/drawingml/2006/main"/>
           <a:p xmlns:a="http://schemas.openxmlformats.org/drawingml/2006/main">
             <a:pPr algn="l">
+              <a:buNone/>
               <a:defRPr sz="1275" b="0">
                 <a:solidFill>
                   <a:srgbClr val="F4FBFF"/>
@@ -8758,6 +8892,7 @@
           <a:lstStyle xmlns:a="http://schemas.openxmlformats.org/drawingml/2006/main"/>
           <a:p xmlns:a="http://schemas.openxmlformats.org/drawingml/2006/main">
             <a:pPr algn="l">
+              <a:buNone/>
               <a:defRPr sz="825" b="1">
                 <a:solidFill>
                   <a:srgbClr val="9AF4FF"/>
@@ -8808,6 +8943,7 @@
           <a:lstStyle xmlns:a="http://schemas.openxmlformats.org/drawingml/2006/main"/>
           <a:p xmlns:a="http://schemas.openxmlformats.org/drawingml/2006/main">
             <a:pPr algn="l">
+              <a:buNone/>
               <a:defRPr sz="1275" b="0">
                 <a:solidFill>
                   <a:srgbClr val="F4FBFF"/>
@@ -8858,6 +8994,7 @@
           <a:lstStyle xmlns:a="http://schemas.openxmlformats.org/drawingml/2006/main"/>
           <a:p xmlns:a="http://schemas.openxmlformats.org/drawingml/2006/main">
             <a:pPr algn="l">
+              <a:buNone/>
               <a:defRPr sz="825" b="1">
                 <a:solidFill>
                   <a:srgbClr val="9AF4FF"/>
@@ -8908,6 +9045,7 @@
           <a:lstStyle xmlns:a="http://schemas.openxmlformats.org/drawingml/2006/main"/>
           <a:p xmlns:a="http://schemas.openxmlformats.org/drawingml/2006/main">
             <a:pPr algn="l">
+              <a:buNone/>
               <a:defRPr sz="1275" b="1">
                 <a:solidFill>
                   <a:srgbClr val="F4FBFF"/>
@@ -8958,6 +9096,7 @@
           <a:lstStyle xmlns:a="http://schemas.openxmlformats.org/drawingml/2006/main"/>
           <a:p xmlns:a="http://schemas.openxmlformats.org/drawingml/2006/main">
             <a:pPr algn="ctr">
+              <a:buNone/>
               <a:defRPr sz="1200" b="0">
                 <a:solidFill>
                   <a:srgbClr val="8EA7B7"/>
@@ -9037,6 +9176,7 @@
           <a:lstStyle xmlns:a="http://schemas.openxmlformats.org/drawingml/2006/main"/>
           <a:p xmlns:a="http://schemas.openxmlformats.org/drawingml/2006/main">
             <a:pPr algn="l">
+              <a:buNone/>
               <a:defRPr sz="825" b="1">
                 <a:solidFill>
                   <a:srgbClr val="38E8FF"/>
@@ -9087,6 +9227,7 @@
           <a:lstStyle xmlns:a="http://schemas.openxmlformats.org/drawingml/2006/main"/>
           <a:p xmlns:a="http://schemas.openxmlformats.org/drawingml/2006/main">
             <a:pPr algn="r">
+              <a:buNone/>
               <a:defRPr sz="825" b="1">
                 <a:solidFill>
                   <a:srgbClr val="506B7B"/>
@@ -9137,6 +9278,7 @@
           <a:lstStyle xmlns:a="http://schemas.openxmlformats.org/drawingml/2006/main"/>
           <a:p xmlns:a="http://schemas.openxmlformats.org/drawingml/2006/main">
             <a:pPr algn="l">
+              <a:buNone/>
               <a:defRPr sz="3150" b="1">
                 <a:solidFill>
                   <a:srgbClr val="F4FBFF"/>
@@ -9149,7 +9291,7 @@
                   <a:srgbClr val="F4FBFF"/>
                 </a:solidFill>
               </a:rPr>
-              <a:t>Every pilot creates the evidence required to sell the next one.</a:t>
+              <a:t>Every pilot creates the evidence required to decide what comes next.</a:t>
             </a:r>
           </a:p>
         </p:txBody>
@@ -9187,6 +9329,7 @@
           <a:lstStyle xmlns:a="http://schemas.openxmlformats.org/drawingml/2006/main"/>
           <a:p xmlns:a="http://schemas.openxmlformats.org/drawingml/2006/main">
             <a:pPr algn="l">
+              <a:buNone/>
               <a:defRPr sz="1350" b="0">
                 <a:solidFill>
                   <a:srgbClr val="8EA7B7"/>
@@ -9199,7 +9342,7 @@
                   <a:srgbClr val="8EA7B7"/>
                 </a:solidFill>
               </a:rPr>
-              <a:t>The customer sees measurable work, not a promise of magic.</a:t>
+              <a:t>Your team sees measured work, exceptions, and corrections—not a promise of magic.</a:t>
             </a:r>
           </a:p>
         </p:txBody>
@@ -9237,6 +9380,7 @@
           <a:lstStyle xmlns:a="http://schemas.openxmlformats.org/drawingml/2006/main"/>
           <a:p xmlns:a="http://schemas.openxmlformats.org/drawingml/2006/main">
             <a:pPr algn="l">
+              <a:buNone/>
               <a:defRPr sz="2250" b="1">
                 <a:solidFill>
                   <a:srgbClr val="38E8FF"/>
@@ -9287,6 +9431,7 @@
           <a:lstStyle xmlns:a="http://schemas.openxmlformats.org/drawingml/2006/main"/>
           <a:p xmlns:a="http://schemas.openxmlformats.org/drawingml/2006/main">
             <a:pPr algn="l">
+              <a:buNone/>
               <a:defRPr sz="1050" b="1">
                 <a:solidFill>
                   <a:srgbClr val="F4FBFF"/>
@@ -9337,6 +9482,7 @@
           <a:lstStyle xmlns:a="http://schemas.openxmlformats.org/drawingml/2006/main"/>
           <a:p xmlns:a="http://schemas.openxmlformats.org/drawingml/2006/main">
             <a:pPr algn="l">
+              <a:buNone/>
               <a:defRPr sz="1275" b="0">
                 <a:solidFill>
                   <a:srgbClr val="8EA7B7"/>
@@ -9387,6 +9533,7 @@
           <a:lstStyle xmlns:a="http://schemas.openxmlformats.org/drawingml/2006/main"/>
           <a:p xmlns:a="http://schemas.openxmlformats.org/drawingml/2006/main">
             <a:pPr algn="ctr">
+              <a:buNone/>
               <a:defRPr sz="1650" b="1">
                 <a:solidFill>
                   <a:srgbClr val="506B7B"/>
@@ -9437,6 +9584,7 @@
           <a:lstStyle xmlns:a="http://schemas.openxmlformats.org/drawingml/2006/main"/>
           <a:p xmlns:a="http://schemas.openxmlformats.org/drawingml/2006/main">
             <a:pPr algn="l">
+              <a:buNone/>
               <a:defRPr sz="2250" b="1">
                 <a:solidFill>
                   <a:srgbClr val="38E8FF"/>
@@ -9487,6 +9635,7 @@
           <a:lstStyle xmlns:a="http://schemas.openxmlformats.org/drawingml/2006/main"/>
           <a:p xmlns:a="http://schemas.openxmlformats.org/drawingml/2006/main">
             <a:pPr algn="l">
+              <a:buNone/>
               <a:defRPr sz="1050" b="1">
                 <a:solidFill>
                   <a:srgbClr val="F4FBFF"/>
@@ -9537,6 +9686,7 @@
           <a:lstStyle xmlns:a="http://schemas.openxmlformats.org/drawingml/2006/main"/>
           <a:p xmlns:a="http://schemas.openxmlformats.org/drawingml/2006/main">
             <a:pPr algn="l">
+              <a:buNone/>
               <a:defRPr sz="1275" b="0">
                 <a:solidFill>
                   <a:srgbClr val="8EA7B7"/>
@@ -9587,6 +9737,7 @@
           <a:lstStyle xmlns:a="http://schemas.openxmlformats.org/drawingml/2006/main"/>
           <a:p xmlns:a="http://schemas.openxmlformats.org/drawingml/2006/main">
             <a:pPr algn="ctr">
+              <a:buNone/>
               <a:defRPr sz="1650" b="1">
                 <a:solidFill>
                   <a:srgbClr val="506B7B"/>
@@ -9637,6 +9788,7 @@
           <a:lstStyle xmlns:a="http://schemas.openxmlformats.org/drawingml/2006/main"/>
           <a:p xmlns:a="http://schemas.openxmlformats.org/drawingml/2006/main">
             <a:pPr algn="l">
+              <a:buNone/>
               <a:defRPr sz="2250" b="1">
                 <a:solidFill>
                   <a:srgbClr val="38E8FF"/>
@@ -9687,6 +9839,7 @@
           <a:lstStyle xmlns:a="http://schemas.openxmlformats.org/drawingml/2006/main"/>
           <a:p xmlns:a="http://schemas.openxmlformats.org/drawingml/2006/main">
             <a:pPr algn="l">
+              <a:buNone/>
               <a:defRPr sz="1050" b="1">
                 <a:solidFill>
                   <a:srgbClr val="F4FBFF"/>
@@ -9737,6 +9890,7 @@
           <a:lstStyle xmlns:a="http://schemas.openxmlformats.org/drawingml/2006/main"/>
           <a:p xmlns:a="http://schemas.openxmlformats.org/drawingml/2006/main">
             <a:pPr algn="l">
+              <a:buNone/>
               <a:defRPr sz="1275" b="0">
                 <a:solidFill>
                   <a:srgbClr val="8EA7B7"/>
@@ -9749,7 +9903,7 @@
                   <a:srgbClr val="8EA7B7"/>
                 </a:solidFill>
               </a:rPr>
-              <a:t>Publish only authentic, authorized outcomes.</a:t>
+              <a:t>Compare response time, workload, quality, and throughput.</a:t>
             </a:r>
           </a:p>
         </p:txBody>
@@ -9787,6 +9941,7 @@
           <a:lstStyle xmlns:a="http://schemas.openxmlformats.org/drawingml/2006/main"/>
           <a:p xmlns:a="http://schemas.openxmlformats.org/drawingml/2006/main">
             <a:pPr algn="ctr">
+              <a:buNone/>
               <a:defRPr sz="1650" b="1">
                 <a:solidFill>
                   <a:srgbClr val="506B7B"/>
@@ -9837,6 +9992,7 @@
           <a:lstStyle xmlns:a="http://schemas.openxmlformats.org/drawingml/2006/main"/>
           <a:p xmlns:a="http://schemas.openxmlformats.org/drawingml/2006/main">
             <a:pPr algn="l">
+              <a:buNone/>
               <a:defRPr sz="2250" b="1">
                 <a:solidFill>
                   <a:srgbClr val="38E8FF"/>
@@ -9887,6 +10043,7 @@
           <a:lstStyle xmlns:a="http://schemas.openxmlformats.org/drawingml/2006/main"/>
           <a:p xmlns:a="http://schemas.openxmlformats.org/drawingml/2006/main">
             <a:pPr algn="l">
+              <a:buNone/>
               <a:defRPr sz="1050" b="1">
                 <a:solidFill>
                   <a:srgbClr val="F4FBFF"/>
@@ -9899,7 +10056,7 @@
                   <a:srgbClr val="F4FBFF"/>
                 </a:solidFill>
               </a:rPr>
-              <a:t>REUSE PROOF</a:t>
+              <a:t>EXPAND OR STOP</a:t>
             </a:r>
           </a:p>
         </p:txBody>
@@ -9937,6 +10094,7 @@
           <a:lstStyle xmlns:a="http://schemas.openxmlformats.org/drawingml/2006/main"/>
           <a:p xmlns:a="http://schemas.openxmlformats.org/drawingml/2006/main">
             <a:pPr algn="l">
+              <a:buNone/>
               <a:defRPr sz="1275" b="0">
                 <a:solidFill>
                   <a:srgbClr val="8EA7B7"/>
@@ -9949,7 +10107,7 @@
                   <a:srgbClr val="8EA7B7"/>
                 </a:solidFill>
               </a:rPr>
-              <a:t>Turn the result into a demo, case study, email, and vertical page.</a:t>
+              <a:t>Scale only when the measured result justifies the next workflow.</a:t>
             </a:r>
           </a:p>
         </p:txBody>
@@ -10022,6 +10180,7 @@
           <a:lstStyle xmlns:a="http://schemas.openxmlformats.org/drawingml/2006/main"/>
           <a:p xmlns:a="http://schemas.openxmlformats.org/drawingml/2006/main">
             <a:pPr algn="l">
+              <a:buNone/>
               <a:defRPr sz="1275" b="1">
                 <a:solidFill>
                   <a:srgbClr val="38E8FF"/>
@@ -10034,7 +10193,7 @@
                   <a:srgbClr val="38E8FF"/>
                 </a:solidFill>
               </a:rPr>
-              <a:t>Creator-style challenge:</a:t>
+              <a:t>Pilot decision:</a:t>
             </a:r>
           </a:p>
         </p:txBody>
@@ -10072,6 +10231,7 @@
           <a:lstStyle xmlns:a="http://schemas.openxmlformats.org/drawingml/2006/main"/>
           <a:p xmlns:a="http://schemas.openxmlformats.org/drawingml/2006/main">
             <a:pPr algn="l">
+              <a:buNone/>
               <a:defRPr sz="1500" b="1">
                 <a:solidFill>
                   <a:srgbClr val="F4FBFF"/>
@@ -10084,7 +10244,7 @@
                   <a:srgbClr val="F4FBFF"/>
                 </a:solidFill>
               </a:rPr>
-              <a:t>Can Jarvis recover 20 owner-hours in 14 days without sending one unapproved message?</a:t>
+              <a:t>Did the workflow improve speed or capacity without removing human control?</a:t>
             </a:r>
           </a:p>
         </p:txBody>
@@ -10151,6 +10311,7 @@
           <a:lstStyle xmlns:a="http://schemas.openxmlformats.org/drawingml/2006/main"/>
           <a:p xmlns:a="http://schemas.openxmlformats.org/drawingml/2006/main">
             <a:pPr algn="l">
+              <a:buNone/>
               <a:defRPr sz="825" b="1">
                 <a:solidFill>
                   <a:srgbClr val="38E8FF"/>
@@ -10163,7 +10324,7 @@
                   <a:srgbClr val="38E8FF"/>
                 </a:solidFill>
               </a:rPr>
-              <a:t>GO-TO-MARKET</a:t>
+              <a:t>WHERE IT FITS</a:t>
             </a:r>
           </a:p>
         </p:txBody>
@@ -10201,6 +10362,7 @@
           <a:lstStyle xmlns:a="http://schemas.openxmlformats.org/drawingml/2006/main"/>
           <a:p xmlns:a="http://schemas.openxmlformats.org/drawingml/2006/main">
             <a:pPr algn="r">
+              <a:buNone/>
               <a:defRPr sz="825" b="1">
                 <a:solidFill>
                   <a:srgbClr val="506B7B"/>
@@ -10251,6 +10413,7 @@
           <a:lstStyle xmlns:a="http://schemas.openxmlformats.org/drawingml/2006/main"/>
           <a:p xmlns:a="http://schemas.openxmlformats.org/drawingml/2006/main">
             <a:pPr algn="l">
+              <a:buNone/>
               <a:defRPr sz="3150" b="1">
                 <a:solidFill>
                   <a:srgbClr val="F4FBFF"/>
@@ -10263,7 +10426,7 @@
                   <a:srgbClr val="F4FBFF"/>
                 </a:solidFill>
               </a:rPr>
-              <a:t>Win one workflow in one vertical, then clone the playbook.</a:t>
+              <a:t>Choose the workflow with visible volume, delay, and ownership.</a:t>
             </a:r>
           </a:p>
         </p:txBody>
@@ -10301,6 +10464,7 @@
           <a:lstStyle xmlns:a="http://schemas.openxmlformats.org/drawingml/2006/main"/>
           <a:p xmlns:a="http://schemas.openxmlformats.org/drawingml/2006/main">
             <a:pPr algn="l">
+              <a:buNone/>
               <a:defRPr sz="1275" b="0">
                 <a:solidFill>
                   <a:srgbClr val="8EA7B7"/>
@@ -10313,7 +10477,7 @@
                   <a:srgbClr val="8EA7B7"/>
                 </a:solidFill>
               </a:rPr>
-              <a:t>The strongest first buyers have expensive leads and obvious follow-up or admin bottlenecks.</a:t>
+              <a:t>The strongest first use cases are repetitive, measurable, and safe to run in approval-only mode.</a:t>
             </a:r>
           </a:p>
         </p:txBody>
@@ -10351,6 +10515,7 @@
           <a:lstStyle xmlns:a="http://schemas.openxmlformats.org/drawingml/2006/main"/>
           <a:p xmlns:a="http://schemas.openxmlformats.org/drawingml/2006/main">
             <a:pPr algn="l">
+              <a:buNone/>
               <a:defRPr sz="900" b="1">
                 <a:solidFill>
                   <a:srgbClr val="38E8FF"/>
@@ -10401,6 +10566,7 @@
           <a:lstStyle xmlns:a="http://schemas.openxmlformats.org/drawingml/2006/main"/>
           <a:p xmlns:a="http://schemas.openxmlformats.org/drawingml/2006/main">
             <a:pPr algn="l">
+              <a:buNone/>
               <a:defRPr sz="1725" b="1">
                 <a:solidFill>
                   <a:srgbClr val="F4FBFF"/>
@@ -10413,7 +10579,7 @@
                   <a:srgbClr val="F4FBFF"/>
                 </a:solidFill>
               </a:rPr>
-              <a:t>Marketing + web agencies</a:t>
+              <a:t>LEAD + INTAKE</a:t>
             </a:r>
           </a:p>
         </p:txBody>
@@ -10451,6 +10617,7 @@
           <a:lstStyle xmlns:a="http://schemas.openxmlformats.org/drawingml/2006/main"/>
           <a:p xmlns:a="http://schemas.openxmlformats.org/drawingml/2006/main">
             <a:pPr algn="l">
+              <a:buNone/>
               <a:defRPr sz="1350" b="0">
                 <a:solidFill>
                   <a:srgbClr val="8EA7B7"/>
@@ -10463,7 +10630,7 @@
                   <a:srgbClr val="8EA7B7"/>
                 </a:solidFill>
               </a:rPr>
-              <a:t>Research, outreach preparation, follow-up</a:t>
+              <a:t>Acknowledge, qualify, research, and route inquiries</a:t>
             </a:r>
           </a:p>
         </p:txBody>
@@ -10532,6 +10699,7 @@
           <a:lstStyle xmlns:a="http://schemas.openxmlformats.org/drawingml/2006/main"/>
           <a:p xmlns:a="http://schemas.openxmlformats.org/drawingml/2006/main">
             <a:pPr algn="l">
+              <a:buNone/>
               <a:defRPr sz="900" b="1">
                 <a:solidFill>
                   <a:srgbClr val="38E8FF"/>
@@ -10582,6 +10750,7 @@
           <a:lstStyle xmlns:a="http://schemas.openxmlformats.org/drawingml/2006/main"/>
           <a:p xmlns:a="http://schemas.openxmlformats.org/drawingml/2006/main">
             <a:pPr algn="l">
+              <a:buNone/>
               <a:defRPr sz="1725" b="1">
                 <a:solidFill>
                   <a:srgbClr val="F4FBFF"/>
@@ -10594,7 +10763,7 @@
                   <a:srgbClr val="F4FBFF"/>
                 </a:solidFill>
               </a:rPr>
-              <a:t>Commercial contractors</a:t>
+              <a:t>DOCUMENT WORK</a:t>
             </a:r>
           </a:p>
         </p:txBody>
@@ -10632,6 +10801,7 @@
           <a:lstStyle xmlns:a="http://schemas.openxmlformats.org/drawingml/2006/main"/>
           <a:p xmlns:a="http://schemas.openxmlformats.org/drawingml/2006/main">
             <a:pPr algn="l">
+              <a:buNone/>
               <a:defRPr sz="1350" b="0">
                 <a:solidFill>
                   <a:srgbClr val="8EA7B7"/>
@@ -10644,7 +10814,7 @@
                   <a:srgbClr val="8EA7B7"/>
                 </a:solidFill>
               </a:rPr>
-              <a:t>Lead qualification, estimate follow-up</a:t>
+              <a:t>Collect, classify, summarize, and flag missing items</a:t>
             </a:r>
           </a:p>
         </p:txBody>
@@ -10713,6 +10883,7 @@
           <a:lstStyle xmlns:a="http://schemas.openxmlformats.org/drawingml/2006/main"/>
           <a:p xmlns:a="http://schemas.openxmlformats.org/drawingml/2006/main">
             <a:pPr algn="l">
+              <a:buNone/>
               <a:defRPr sz="900" b="1">
                 <a:solidFill>
                   <a:srgbClr val="38E8FF"/>
@@ -10763,6 +10934,7 @@
           <a:lstStyle xmlns:a="http://schemas.openxmlformats.org/drawingml/2006/main"/>
           <a:p xmlns:a="http://schemas.openxmlformats.org/drawingml/2006/main">
             <a:pPr algn="l">
+              <a:buNone/>
               <a:defRPr sz="1725" b="1">
                 <a:solidFill>
                   <a:srgbClr val="F4FBFF"/>
@@ -10775,7 +10947,7 @@
                   <a:srgbClr val="F4FBFF"/>
                 </a:solidFill>
               </a:rPr>
-              <a:t>Recruiting firms</a:t>
+              <a:t>COORDINATION</a:t>
             </a:r>
           </a:p>
         </p:txBody>
@@ -10813,6 +10985,7 @@
           <a:lstStyle xmlns:a="http://schemas.openxmlformats.org/drawingml/2006/main"/>
           <a:p xmlns:a="http://schemas.openxmlformats.org/drawingml/2006/main">
             <a:pPr algn="l">
+              <a:buNone/>
               <a:defRPr sz="1350" b="0">
                 <a:solidFill>
                   <a:srgbClr val="8EA7B7"/>
@@ -10825,7 +10998,7 @@
                   <a:srgbClr val="8EA7B7"/>
                 </a:solidFill>
               </a:rPr>
-              <a:t>Candidate research, summaries, outreach</a:t>
+              <a:t>Prepare schedules, status updates, and internal handoffs</a:t>
             </a:r>
           </a:p>
         </p:txBody>
@@ -10894,6 +11067,7 @@
           <a:lstStyle xmlns:a="http://schemas.openxmlformats.org/drawingml/2006/main"/>
           <a:p xmlns:a="http://schemas.openxmlformats.org/drawingml/2006/main">
             <a:pPr algn="l">
+              <a:buNone/>
               <a:defRPr sz="900" b="1">
                 <a:solidFill>
                   <a:srgbClr val="38E8FF"/>
@@ -10944,6 +11118,7 @@
           <a:lstStyle xmlns:a="http://schemas.openxmlformats.org/drawingml/2006/main"/>
           <a:p xmlns:a="http://schemas.openxmlformats.org/drawingml/2006/main">
             <a:pPr algn="l">
+              <a:buNone/>
               <a:defRPr sz="1725" b="1">
                 <a:solidFill>
                   <a:srgbClr val="F4FBFF"/>
@@ -10956,7 +11131,7 @@
                   <a:srgbClr val="F4FBFF"/>
                 </a:solidFill>
               </a:rPr>
-              <a:t>Consultants + accountants</a:t>
+              <a:t>REPORTING</a:t>
             </a:r>
           </a:p>
         </p:txBody>
@@ -10994,6 +11169,7 @@
           <a:lstStyle xmlns:a="http://schemas.openxmlformats.org/drawingml/2006/main"/>
           <a:p xmlns:a="http://schemas.openxmlformats.org/drawingml/2006/main">
             <a:pPr algn="l">
+              <a:buNone/>
               <a:defRPr sz="1350" b="0">
                 <a:solidFill>
                   <a:srgbClr val="8EA7B7"/>
@@ -11006,7 +11182,7 @@
                   <a:srgbClr val="8EA7B7"/>
                 </a:solidFill>
               </a:rPr>
-              <a:t>Intake, document collection, client updates</a:t>
+              <a:t>Turn activity into decision-ready summaries</a:t>
             </a:r>
           </a:p>
         </p:txBody>
@@ -11075,6 +11251,7 @@
           <a:lstStyle xmlns:a="http://schemas.openxmlformats.org/drawingml/2006/main"/>
           <a:p xmlns:a="http://schemas.openxmlformats.org/drawingml/2006/main">
             <a:pPr algn="ctr">
+              <a:buNone/>
               <a:defRPr sz="1125" b="1">
                 <a:solidFill>
                   <a:srgbClr val="9AF4FF"/>
@@ -11087,7 +11264,7 @@
                   <a:srgbClr val="9AF4FF"/>
                 </a:solidFill>
               </a:rPr>
-              <a:t>Qualification: 5–50 employees · $2K+ offer value · repeatable work · owner can approve a pilot quickly</a:t>
+              <a:t>Good first workflow: repeated weekly · measurable baseline · named approver · reversible pilot · no autonomous consequential action</a:t>
             </a:r>
           </a:p>
         </p:txBody>
@@ -11154,6 +11331,7 @@
           <a:lstStyle xmlns:a="http://schemas.openxmlformats.org/drawingml/2006/main"/>
           <a:p xmlns:a="http://schemas.openxmlformats.org/drawingml/2006/main">
             <a:pPr algn="l">
+              <a:buNone/>
               <a:defRPr sz="825" b="1">
                 <a:solidFill>
                   <a:srgbClr val="38E8FF"/>
@@ -11166,7 +11344,7 @@
                   <a:srgbClr val="38E8FF"/>
                 </a:solidFill>
               </a:rPr>
-              <a:t>THE BUSINESS MODEL</a:t>
+              <a:t>THE ENGAGEMENT</a:t>
             </a:r>
           </a:p>
         </p:txBody>
@@ -11204,6 +11382,7 @@
           <a:lstStyle xmlns:a="http://schemas.openxmlformats.org/drawingml/2006/main"/>
           <a:p xmlns:a="http://schemas.openxmlformats.org/drawingml/2006/main">
             <a:pPr algn="r">
+              <a:buNone/>
               <a:defRPr sz="825" b="1">
                 <a:solidFill>
                   <a:srgbClr val="506B7B"/>
@@ -11254,6 +11433,7 @@
           <a:lstStyle xmlns:a="http://schemas.openxmlformats.org/drawingml/2006/main"/>
           <a:p xmlns:a="http://schemas.openxmlformats.org/drawingml/2006/main">
             <a:pPr algn="l">
+              <a:buNone/>
               <a:defRPr sz="3150" b="1">
                 <a:solidFill>
                   <a:srgbClr val="F4FBFF"/>
@@ -11266,7 +11446,7 @@
                   <a:srgbClr val="F4FBFF"/>
                 </a:solidFill>
               </a:rPr>
-              <a:t>A low-risk entry creates the path to recurring operations.</a:t>
+              <a:t>Start with a blueprint, prove one workflow, then expand.</a:t>
             </a:r>
           </a:p>
         </p:txBody>
@@ -11304,6 +11484,7 @@
           <a:lstStyle xmlns:a="http://schemas.openxmlformats.org/drawingml/2006/main"/>
           <a:p xmlns:a="http://schemas.openxmlformats.org/drawingml/2006/main">
             <a:pPr algn="l">
+              <a:buNone/>
               <a:defRPr sz="1350" b="0">
                 <a:solidFill>
                   <a:srgbClr val="8EA7B7"/>
@@ -11316,7 +11497,7 @@
                   <a:srgbClr val="8EA7B7"/>
                 </a:solidFill>
               </a:rPr>
-              <a:t>Launch pricing is testable; value and scope determine standard pricing.</a:t>
+              <a:t>Scope and risk determine final pricing; every stage has an approval gate.</a:t>
             </a:r>
           </a:p>
         </p:txBody>
@@ -11354,6 +11535,7 @@
           <a:lstStyle xmlns:a="http://schemas.openxmlformats.org/drawingml/2006/main"/>
           <a:p xmlns:a="http://schemas.openxmlformats.org/drawingml/2006/main">
             <a:pPr algn="l">
+              <a:buNone/>
               <a:defRPr sz="2850" b="1">
                 <a:solidFill>
                   <a:srgbClr val="8DFFBC"/>
@@ -11404,6 +11586,7 @@
           <a:lstStyle xmlns:a="http://schemas.openxmlformats.org/drawingml/2006/main"/>
           <a:p xmlns:a="http://schemas.openxmlformats.org/drawingml/2006/main">
             <a:pPr algn="l">
+              <a:buNone/>
               <a:defRPr sz="1500" b="1">
                 <a:solidFill>
                   <a:srgbClr val="F4FBFF"/>
@@ -11454,6 +11637,7 @@
           <a:lstStyle xmlns:a="http://schemas.openxmlformats.org/drawingml/2006/main"/>
           <a:p xmlns:a="http://schemas.openxmlformats.org/drawingml/2006/main">
             <a:pPr algn="l">
+              <a:buNone/>
               <a:defRPr sz="1200" b="0">
                 <a:solidFill>
                   <a:srgbClr val="8EA7B7"/>
@@ -11535,6 +11719,7 @@
           <a:lstStyle xmlns:a="http://schemas.openxmlformats.org/drawingml/2006/main"/>
           <a:p xmlns:a="http://schemas.openxmlformats.org/drawingml/2006/main">
             <a:pPr algn="l">
+              <a:buNone/>
               <a:defRPr sz="2850" b="1">
                 <a:solidFill>
                   <a:srgbClr val="38E8FF"/>
@@ -11547,7 +11732,7 @@
                   <a:srgbClr val="38E8FF"/>
                 </a:solidFill>
               </a:rPr>
-              <a:t>$1.5K+</a:t>
+              <a:t>$7.5K+</a:t>
             </a:r>
           </a:p>
         </p:txBody>
@@ -11585,6 +11770,7 @@
           <a:lstStyle xmlns:a="http://schemas.openxmlformats.org/drawingml/2006/main"/>
           <a:p xmlns:a="http://schemas.openxmlformats.org/drawingml/2006/main">
             <a:pPr algn="l">
+              <a:buNone/>
               <a:defRPr sz="1500" b="1">
                 <a:solidFill>
                   <a:srgbClr val="F4FBFF"/>
@@ -11597,7 +11783,7 @@
                   <a:srgbClr val="F4FBFF"/>
                 </a:solidFill>
               </a:rPr>
-              <a:t>Proof Sprint</a:t>
+              <a:t>3-Agent Launch</a:t>
             </a:r>
           </a:p>
         </p:txBody>
@@ -11635,6 +11821,7 @@
           <a:lstStyle xmlns:a="http://schemas.openxmlformats.org/drawingml/2006/main"/>
           <a:p xmlns:a="http://schemas.openxmlformats.org/drawingml/2006/main">
             <a:pPr algn="l">
+              <a:buNone/>
               <a:defRPr sz="1200" b="0">
                 <a:solidFill>
                   <a:srgbClr val="8EA7B7"/>
@@ -11647,7 +11834,7 @@
                   <a:srgbClr val="8EA7B7"/>
                 </a:solidFill>
               </a:rPr>
-              <a:t>One supervised workflow, baseline, integration, before/after score</a:t>
+              <a:t>Three configured specialists, integrations, tests, and approval rules</a:t>
             </a:r>
           </a:p>
         </p:txBody>
@@ -11716,6 +11903,7 @@
           <a:lstStyle xmlns:a="http://schemas.openxmlformats.org/drawingml/2006/main"/>
           <a:p xmlns:a="http://schemas.openxmlformats.org/drawingml/2006/main">
             <a:pPr algn="l">
+              <a:buNone/>
               <a:defRPr sz="2850" b="1">
                 <a:solidFill>
                   <a:srgbClr val="38E8FF"/>
@@ -11728,7 +11916,7 @@
                   <a:srgbClr val="38E8FF"/>
                 </a:solidFill>
               </a:rPr>
-              <a:t>$2.5K+/mo</a:t>
+              <a:t>$3K+/mo</a:t>
             </a:r>
           </a:p>
         </p:txBody>
@@ -11766,6 +11954,7 @@
           <a:lstStyle xmlns:a="http://schemas.openxmlformats.org/drawingml/2006/main"/>
           <a:p xmlns:a="http://schemas.openxmlformats.org/drawingml/2006/main">
             <a:pPr algn="l">
+              <a:buNone/>
               <a:defRPr sz="1500" b="1">
                 <a:solidFill>
                   <a:srgbClr val="F4FBFF"/>
@@ -11778,7 +11967,7 @@
                   <a:srgbClr val="F4FBFF"/>
                 </a:solidFill>
               </a:rPr>
-              <a:t>Managed Workforce</a:t>
+              <a:t>Managed AI Operations</a:t>
             </a:r>
           </a:p>
         </p:txBody>
@@ -11816,6 +12005,7 @@
           <a:lstStyle xmlns:a="http://schemas.openxmlformats.org/drawingml/2006/main"/>
           <a:p xmlns:a="http://schemas.openxmlformats.org/drawingml/2006/main">
             <a:pPr algn="l">
+              <a:buNone/>
               <a:defRPr sz="1200" b="0">
                 <a:solidFill>
                   <a:srgbClr val="8EA7B7"/>
@@ -11828,7 +12018,7 @@
                   <a:srgbClr val="8EA7B7"/>
                 </a:solidFill>
               </a:rPr>
-              <a:t>Up to three workflows, monitoring, optimization, reporting</a:t>
+              <a:t>Quality review, optimization, governance reporting, and new-agent allowance</a:t>
             </a:r>
           </a:p>
         </p:txBody>
@@ -11897,6 +12087,7 @@
           <a:lstStyle xmlns:a="http://schemas.openxmlformats.org/drawingml/2006/main"/>
           <a:p xmlns:a="http://schemas.openxmlformats.org/drawingml/2006/main">
             <a:pPr algn="l">
+              <a:buNone/>
               <a:defRPr sz="2850" b="1">
                 <a:solidFill>
                   <a:srgbClr val="38E8FF"/>
@@ -11909,7 +12100,7 @@
                   <a:srgbClr val="38E8FF"/>
                 </a:solidFill>
               </a:rPr>
-              <a:t>$5K+/mo</a:t>
+              <a:t>CUSTOM</a:t>
             </a:r>
           </a:p>
         </p:txBody>
@@ -11947,6 +12138,7 @@
           <a:lstStyle xmlns:a="http://schemas.openxmlformats.org/drawingml/2006/main"/>
           <a:p xmlns:a="http://schemas.openxmlformats.org/drawingml/2006/main">
             <a:pPr algn="l">
+              <a:buNone/>
               <a:defRPr sz="1500" b="1">
                 <a:solidFill>
                   <a:srgbClr val="F4FBFF"/>
@@ -11997,6 +12189,7 @@
           <a:lstStyle xmlns:a="http://schemas.openxmlformats.org/drawingml/2006/main"/>
           <a:p xmlns:a="http://schemas.openxmlformats.org/drawingml/2006/main">
             <a:pPr algn="l">
+              <a:buNone/>
               <a:defRPr sz="1200" b="0">
                 <a:solidFill>
                   <a:srgbClr val="8EA7B7"/>
@@ -12009,7 +12202,7 @@
                   <a:srgbClr val="8EA7B7"/>
                 </a:solidFill>
               </a:rPr>
-              <a:t>Expanded workflows, weekly strategy, priority implementation</a:t>
+              <a:t>Expanded workflows, weekly strategy, and priority implementation</a:t>
             </a:r>
           </a:p>
         </p:txBody>
@@ -12078,6 +12271,7 @@
           <a:lstStyle xmlns:a="http://schemas.openxmlformats.org/drawingml/2006/main"/>
           <a:p xmlns:a="http://schemas.openxmlformats.org/drawingml/2006/main">
             <a:pPr algn="ctr">
+              <a:buNone/>
               <a:defRPr sz="1875" b="1">
                 <a:solidFill>
                   <a:srgbClr val="F4FBFF"/>
@@ -12090,7 +12284,7 @@
                   <a:srgbClr val="F4FBFF"/>
                 </a:solidFill>
               </a:rPr>
-              <a:t>Blueprint  →  Sprint  →  Subscription  →  Expansion  →  Referral</a:t>
+              <a:t>Blueprint  →  Approved scope  →  Implementation  →  Managed operations  →  Expansion</a:t>
             </a:r>
           </a:p>
         </p:txBody>
@@ -12157,6 +12351,7 @@
           <a:lstStyle xmlns:a="http://schemas.openxmlformats.org/drawingml/2006/main"/>
           <a:p xmlns:a="http://schemas.openxmlformats.org/drawingml/2006/main">
             <a:pPr algn="l">
+              <a:buNone/>
               <a:defRPr sz="825" b="1">
                 <a:solidFill>
                   <a:srgbClr val="38E8FF"/>
@@ -12169,7 +12364,7 @@
                   <a:srgbClr val="38E8FF"/>
                 </a:solidFill>
               </a:rPr>
-              <a:t>ILLUSTRATIVE ECONOMICS</a:t>
+              <a:t>THE PILOT SCORECARD</a:t>
             </a:r>
           </a:p>
         </p:txBody>
@@ -12207,6 +12402,7 @@
           <a:lstStyle xmlns:a="http://schemas.openxmlformats.org/drawingml/2006/main"/>
           <a:p xmlns:a="http://schemas.openxmlformats.org/drawingml/2006/main">
             <a:pPr algn="r">
+              <a:buNone/>
               <a:defRPr sz="825" b="1">
                 <a:solidFill>
                   <a:srgbClr val="506B7B"/>
@@ -12257,6 +12453,7 @@
           <a:lstStyle xmlns:a="http://schemas.openxmlformats.org/drawingml/2006/main"/>
           <a:p xmlns:a="http://schemas.openxmlformats.org/drawingml/2006/main">
             <a:pPr algn="l">
+              <a:buNone/>
               <a:defRPr sz="3150" b="1">
                 <a:solidFill>
                   <a:srgbClr val="F4FBFF"/>
@@ -12269,7 +12466,7 @@
                   <a:srgbClr val="F4FBFF"/>
                 </a:solidFill>
               </a:rPr>
-              <a:t>Recurring revenue can scale—after retention and delivery costs are proven.</a:t>
+              <a:t>Expansion follows measured evidence—not projected savings.</a:t>
             </a:r>
           </a:p>
         </p:txBody>
@@ -12307,6 +12504,7 @@
           <a:lstStyle xmlns:a="http://schemas.openxmlformats.org/drawingml/2006/main"/>
           <a:p xmlns:a="http://schemas.openxmlformats.org/drawingml/2006/main">
             <a:pPr algn="l">
+              <a:buNone/>
               <a:defRPr sz="1350" b="0">
                 <a:solidFill>
                   <a:srgbClr val="8EA7B7"/>
@@ -12319,14 +12517,14 @@
                   <a:srgbClr val="8EA7B7"/>
                 </a:solidFill>
               </a:rPr>
-              <a:t>Planning scenarios, not forecasts. Gross profit excludes founder labor and overhead.</a:t>
+              <a:t>Agree on baselines and decision rules before implementation begins.</a:t>
             </a:r>
           </a:p>
         </p:txBody>
       </p:sp>
       <p:graphicFrame>
         <p:nvGraphicFramePr>
-          <p:cNvPr id="23" name="Chart"/>
+          <p:cNvPr id="24" name="Chart"/>
           <p:cNvGraphicFramePr/>
           <p:nvPr/>
         </p:nvGraphicFramePr>
@@ -12336,7 +12534,7 @@
         </p:xfrm>
         <a:graphic xmlns:a="http://schemas.openxmlformats.org/drawingml/2006/main">
           <a:graphicData uri="http://schemas.openxmlformats.org/drawingml/2006/chart">
-            <c:chart xmlns:r="http://schemas.openxmlformats.org/officeDocument/2006/relationships" xmlns:c="http://schemas.openxmlformats.org/drawingml/2006/chart" r:id="R6c43f0fa44b747e8"/>
+            <c:chart xmlns:r="http://schemas.openxmlformats.org/officeDocument/2006/relationships" xmlns:c="http://schemas.openxmlformats.org/drawingml/2006/chart" r:id="Rabf2c29c469d4a63"/>
           </a:graphicData>
         </a:graphic>
       </p:graphicFrame>
@@ -12408,6 +12606,7 @@
           <a:lstStyle xmlns:a="http://schemas.openxmlformats.org/drawingml/2006/main"/>
           <a:p xmlns:a="http://schemas.openxmlformats.org/drawingml/2006/main">
             <a:pPr algn="l">
+              <a:buNone/>
               <a:defRPr sz="825" b="1">
                 <a:solidFill>
                   <a:srgbClr val="38E8FF"/>
@@ -12420,7 +12619,7 @@
                   <a:srgbClr val="38E8FF"/>
                 </a:solidFill>
               </a:rPr>
-              <a:t>MODEL ASSUMPTIONS</a:t>
+              <a:t>DECISION MEASURES</a:t>
             </a:r>
           </a:p>
         </p:txBody>
@@ -12458,6 +12657,7 @@
           <a:lstStyle xmlns:a="http://schemas.openxmlformats.org/drawingml/2006/main"/>
           <a:p xmlns:a="http://schemas.openxmlformats.org/drawingml/2006/main">
             <a:pPr algn="l">
+              <a:buNone/>
               <a:defRPr sz="1200" b="1">
                 <a:solidFill>
                   <a:srgbClr val="38E8FF"/>
@@ -12508,6 +12708,7 @@
           <a:lstStyle xmlns:a="http://schemas.openxmlformats.org/drawingml/2006/main"/>
           <a:p xmlns:a="http://schemas.openxmlformats.org/drawingml/2006/main">
             <a:pPr algn="l">
+              <a:buNone/>
               <a:defRPr sz="1200" b="0">
                 <a:solidFill>
                   <a:srgbClr val="F4FBFF"/>
@@ -12520,7 +12721,7 @@
                   <a:srgbClr val="F4FBFF"/>
                 </a:solidFill>
               </a:rPr>
-              <a:t>$2,500 monthly subscription</a:t>
+              <a:t>Response time + completion rate</a:t>
             </a:r>
           </a:p>
         </p:txBody>
@@ -12558,6 +12759,7 @@
           <a:lstStyle xmlns:a="http://schemas.openxmlformats.org/drawingml/2006/main"/>
           <a:p xmlns:a="http://schemas.openxmlformats.org/drawingml/2006/main">
             <a:pPr algn="l">
+              <a:buNone/>
               <a:defRPr sz="1200" b="1">
                 <a:solidFill>
                   <a:srgbClr val="38E8FF"/>
@@ -12608,6 +12810,7 @@
           <a:lstStyle xmlns:a="http://schemas.openxmlformats.org/drawingml/2006/main"/>
           <a:p xmlns:a="http://schemas.openxmlformats.org/drawingml/2006/main">
             <a:pPr algn="l">
+              <a:buNone/>
               <a:defRPr sz="1200" b="0">
                 <a:solidFill>
                   <a:srgbClr val="F4FBFF"/>
@@ -12620,7 +12823,7 @@
                   <a:srgbClr val="F4FBFF"/>
                 </a:solidFill>
               </a:rPr>
-              <a:t>$1,500 new proof sprint</a:t>
+              <a:t>Staff hours + exception volume</a:t>
             </a:r>
           </a:p>
         </p:txBody>
@@ -12658,6 +12861,7 @@
           <a:lstStyle xmlns:a="http://schemas.openxmlformats.org/drawingml/2006/main"/>
           <a:p xmlns:a="http://schemas.openxmlformats.org/drawingml/2006/main">
             <a:pPr algn="l">
+              <a:buNone/>
               <a:defRPr sz="1200" b="1">
                 <a:solidFill>
                   <a:srgbClr val="38E8FF"/>
@@ -12708,6 +12912,7 @@
           <a:lstStyle xmlns:a="http://schemas.openxmlformats.org/drawingml/2006/main"/>
           <a:p xmlns:a="http://schemas.openxmlformats.org/drawingml/2006/main">
             <a:pPr algn="l">
+              <a:buNone/>
               <a:defRPr sz="1200" b="0">
                 <a:solidFill>
                   <a:srgbClr val="F4FBFF"/>
@@ -12720,7 +12925,7 @@
                   <a:srgbClr val="F4FBFF"/>
                 </a:solidFill>
               </a:rPr>
-              <a:t>20% variable software + support</a:t>
+              <a:t>Accuracy + correction rate</a:t>
             </a:r>
           </a:p>
         </p:txBody>
@@ -12758,6 +12963,7 @@
           <a:lstStyle xmlns:a="http://schemas.openxmlformats.org/drawingml/2006/main"/>
           <a:p xmlns:a="http://schemas.openxmlformats.org/drawingml/2006/main">
             <a:pPr algn="l">
+              <a:buNone/>
               <a:defRPr sz="1200" b="1">
                 <a:solidFill>
                   <a:srgbClr val="38E8FF"/>
@@ -12808,6 +13014,7 @@
           <a:lstStyle xmlns:a="http://schemas.openxmlformats.org/drawingml/2006/main"/>
           <a:p xmlns:a="http://schemas.openxmlformats.org/drawingml/2006/main">
             <a:pPr algn="l">
+              <a:buNone/>
               <a:defRPr sz="1200" b="0">
                 <a:solidFill>
                   <a:srgbClr val="F4FBFF"/>
@@ -12820,7 +13027,7 @@
                   <a:srgbClr val="F4FBFF"/>
                 </a:solidFill>
               </a:rPr>
-              <a:t>4% monthly churn once established</a:t>
+              <a:t>Customer or owner experience</a:t>
             </a:r>
           </a:p>
         </p:txBody>
@@ -12858,6 +13065,7 @@
           <a:lstStyle xmlns:a="http://schemas.openxmlformats.org/drawingml/2006/main"/>
           <a:p xmlns:a="http://schemas.openxmlformats.org/drawingml/2006/main">
             <a:pPr algn="l">
+              <a:buNone/>
               <a:defRPr sz="1200" b="1">
                 <a:solidFill>
                   <a:srgbClr val="38E8FF"/>
@@ -12908,6 +13116,7 @@
           <a:lstStyle xmlns:a="http://schemas.openxmlformats.org/drawingml/2006/main"/>
           <a:p xmlns:a="http://schemas.openxmlformats.org/drawingml/2006/main">
             <a:pPr algn="l">
+              <a:buNone/>
               <a:defRPr sz="1200" b="0">
                 <a:solidFill>
                   <a:srgbClr val="F4FBFF"/>
@@ -12920,7 +13129,7 @@
                   <a:srgbClr val="F4FBFF"/>
                 </a:solidFill>
               </a:rPr>
-              <a:t>Excludes founder labor + overhead</a:t>
+              <a:t>Operating cost + support burden</a:t>
             </a:r>
           </a:p>
         </p:txBody>
@@ -12958,6 +13167,7 @@
           <a:lstStyle xmlns:a="http://schemas.openxmlformats.org/drawingml/2006/main"/>
           <a:p xmlns:a="http://schemas.openxmlformats.org/drawingml/2006/main">
             <a:pPr algn="ctr">
+              <a:buNone/>
               <a:defRPr sz="975" b="0">
                 <a:solidFill>
                   <a:srgbClr val="8EA7B7"/>
@@ -12970,7 +13180,7 @@
                   <a:srgbClr val="8EA7B7"/>
                 </a:solidFill>
               </a:rPr>
-              <a:t>Real conversion, acquisition cost, delivery time, retention, refunds, and support must replace assumptions before investment claims.</a:t>
+              <a:t>Illustrative index: lower is better for response/admin effort; higher is better for completion. Agree baselines before launch.</a:t>
             </a:r>
           </a:p>
         </p:txBody>

</xml_diff>